<commit_message>
Präsentation Mitarbeit: Unterrichtsstörungen mit Stufenplan ergänzt
Co-Authored-By: Claude Opus 5.5 <noreply@anthropic.com>
Claude-Session: https://claude.ai/code/session_01KXvLXHMYPnCyEbMRgNaaYs
</commit_message>
<xml_diff>
--- a/Deutsch_7A/Mitarbeit/Muendliche_Noten_Kriterien.pptx
+++ b/Deutsch_7A/Mitarbeit/Muendliche_Noten_Kriterien.pptx
@@ -14,9 +14,11 @@
     <p:sldId id="262" r:id="rId8"/>
     <p:sldId id="263" r:id="rId9"/>
     <p:sldId id="264" r:id="rId10"/>
+    <p:sldId id="265" r:id="rId11"/>
+    <p:sldId id="266" r:id="rId12"/>
   </p:sldIdLst>
   <p:notesMasterIdLst>
-    <p:notesMasterId r:id="rId11"/>
+    <p:notesMasterId r:id="rId13"/>
   </p:notesMasterIdLst>
   <p:sldSz cx="12192000" cy="6858000"/>
   <p:notesSz cx="6858000" cy="12192000"/>
@@ -552,6 +554,182 @@
 </p:notes>
 </file>
 
+<file path=ppt/notesSlides/notesSlide10.xml><?xml version="1.0" encoding="utf-8"?>
+<p:notes xmlns:a="http://schemas.openxmlformats.org/drawingml/2006/main" xmlns:r="http://schemas.openxmlformats.org/officeDocument/2006/relationships" xmlns:p="http://schemas.openxmlformats.org/presentationml/2006/main">
+  <p:cSld>
+    <p:spTree>
+      <p:nvGrpSpPr>
+        <p:cNvPr id="1" name=""/>
+        <p:cNvGrpSpPr/>
+        <p:nvPr/>
+      </p:nvGrpSpPr>
+      <p:grpSpPr>
+        <a:xfrm>
+          <a:off x="0" y="0"/>
+          <a:ext cx="0" cy="0"/>
+          <a:chOff x="0" y="0"/>
+          <a:chExt cx="0" cy="0"/>
+        </a:xfrm>
+      </p:grpSpPr>
+      <p:sp>
+        <p:nvSpPr>
+          <p:cNvPr id="2" name="Slide Image Placeholder 1"/>
+          <p:cNvSpPr>
+            <a:spLocks noGrp="1" noRot="1" noChangeAspect="1"/>
+          </p:cNvSpPr>
+          <p:nvPr>
+            <p:ph type="sldImg"/>
+          </p:nvPr>
+        </p:nvSpPr>
+        <p:spPr/>
+      </p:sp>
+      <p:sp>
+        <p:nvSpPr>
+          <p:cNvPr id="3" name="Notes Placeholder 2"/>
+          <p:cNvSpPr>
+            <a:spLocks noGrp="1"/>
+          </p:cNvSpPr>
+          <p:nvPr>
+            <p:ph type="body" idx="1"/>
+          </p:nvPr>
+        </p:nvSpPr>
+        <p:spPr/>
+        <p:txBody>
+          <a:bodyPr/>
+          <a:lstStyle/>
+          <a:p>
+            <a:r>
+              <a:rPr lang="en-US" dirty="0"/>
+              <a:t>Konkrete Tipps; gerne gemeinsam an die Tafel schreiben lassen, was sich jeder bis Weihnachten vornimmt.</a:t>
+            </a:r>
+            <a:endParaRPr lang="en-US" dirty="0"/>
+          </a:p>
+        </p:txBody>
+      </p:sp>
+      <p:sp>
+        <p:nvSpPr>
+          <p:cNvPr id="4" name="Slide Number Placeholder 3"/>
+          <p:cNvSpPr>
+            <a:spLocks noGrp="1"/>
+          </p:cNvSpPr>
+          <p:nvPr>
+            <p:ph type="sldNum" sz="quarter" idx="10"/>
+          </p:nvPr>
+        </p:nvSpPr>
+        <p:spPr/>
+        <p:txBody>
+          <a:bodyPr/>
+          <a:lstStyle/>
+          <a:p>
+            <a:fld id="{F7021451-1387-4CA6-816F-3879F97B5CBC}" type="slidenum">
+              <a:rPr lang="en-US"/>
+              <a:t>10</a:t>
+            </a:fld>
+            <a:endParaRPr lang="en-US"/>
+          </a:p>
+        </p:txBody>
+      </p:sp>
+    </p:spTree>
+    <p:extLst>
+      <p:ext uri="{BB962C8B-B14F-4D97-AF65-F5344CB8AC3E}">
+        <p14:creationId xmlns:p14="http://schemas.microsoft.com/office/powerpoint/2010/main" val="1024086991"/>
+      </p:ext>
+    </p:extLst>
+  </p:cSld>
+  <p:clrMapOvr>
+    <a:masterClrMapping/>
+  </p:clrMapOvr>
+</p:notes>
+</file>
+
+<file path=ppt/notesSlides/notesSlide11.xml><?xml version="1.0" encoding="utf-8"?>
+<p:notes xmlns:a="http://schemas.openxmlformats.org/drawingml/2006/main" xmlns:r="http://schemas.openxmlformats.org/officeDocument/2006/relationships" xmlns:p="http://schemas.openxmlformats.org/presentationml/2006/main">
+  <p:cSld>
+    <p:spTree>
+      <p:nvGrpSpPr>
+        <p:cNvPr id="1" name=""/>
+        <p:cNvGrpSpPr/>
+        <p:nvPr/>
+      </p:nvGrpSpPr>
+      <p:grpSpPr>
+        <a:xfrm>
+          <a:off x="0" y="0"/>
+          <a:ext cx="0" cy="0"/>
+          <a:chOff x="0" y="0"/>
+          <a:chExt cx="0" cy="0"/>
+        </a:xfrm>
+      </p:grpSpPr>
+      <p:sp>
+        <p:nvSpPr>
+          <p:cNvPr id="2" name="Slide Image Placeholder 1"/>
+          <p:cNvSpPr>
+            <a:spLocks noGrp="1" noRot="1" noChangeAspect="1"/>
+          </p:cNvSpPr>
+          <p:nvPr>
+            <p:ph type="sldImg"/>
+          </p:nvPr>
+        </p:nvSpPr>
+        <p:spPr/>
+      </p:sp>
+      <p:sp>
+        <p:nvSpPr>
+          <p:cNvPr id="3" name="Notes Placeholder 2"/>
+          <p:cNvSpPr>
+            <a:spLocks noGrp="1"/>
+          </p:cNvSpPr>
+          <p:nvPr>
+            <p:ph type="body" idx="1"/>
+          </p:nvPr>
+        </p:nvSpPr>
+        <p:spPr/>
+        <p:txBody>
+          <a:bodyPr/>
+          <a:lstStyle/>
+          <a:p>
+            <a:r>
+              <a:rPr lang="en-US" dirty="0"/>
+              <a:t>Noten am besten einzeln mitteilen (z. B. während einer Arbeitsphase), nicht im Plenum.</a:t>
+            </a:r>
+            <a:endParaRPr lang="en-US" dirty="0"/>
+          </a:p>
+        </p:txBody>
+      </p:sp>
+      <p:sp>
+        <p:nvSpPr>
+          <p:cNvPr id="4" name="Slide Number Placeholder 3"/>
+          <p:cNvSpPr>
+            <a:spLocks noGrp="1"/>
+          </p:cNvSpPr>
+          <p:nvPr>
+            <p:ph type="sldNum" sz="quarter" idx="10"/>
+          </p:nvPr>
+        </p:nvSpPr>
+        <p:spPr/>
+        <p:txBody>
+          <a:bodyPr/>
+          <a:lstStyle/>
+          <a:p>
+            <a:fld id="{F7021451-1387-4CA6-816F-3879F97B5CBC}" type="slidenum">
+              <a:rPr lang="en-US"/>
+              <a:t>11</a:t>
+            </a:fld>
+            <a:endParaRPr lang="en-US"/>
+          </a:p>
+        </p:txBody>
+      </p:sp>
+    </p:spTree>
+    <p:extLst>
+      <p:ext uri="{BB962C8B-B14F-4D97-AF65-F5344CB8AC3E}">
+        <p14:creationId xmlns:p14="http://schemas.microsoft.com/office/powerpoint/2010/main" val="1024086991"/>
+      </p:ext>
+    </p:extLst>
+  </p:cSld>
+  <p:clrMapOvr>
+    <a:masterClrMapping/>
+  </p:clrMapOvr>
+</p:notes>
+</file>
+
 <file path=ppt/notesSlides/notesSlide2.xml><?xml version="1.0" encoding="utf-8"?>
 <p:notes xmlns:a="http://schemas.openxmlformats.org/drawingml/2006/main" xmlns:r="http://schemas.openxmlformats.org/officeDocument/2006/relationships" xmlns:p="http://schemas.openxmlformats.org/presentationml/2006/main">
   <p:cSld>
@@ -1126,7 +1304,7 @@
           <a:p>
             <a:r>
               <a:rPr lang="en-US" dirty="0"/>
-              <a:t>Konkrete Tipps; gerne gemeinsam an die Tafel schreiben lassen, was sich jeder bis Weihnachten vornimmt.</a:t>
+              <a:t>Kurz mit der Klasse sammeln, dann die Folie zeigen. Wichtig: Es geht darum, dass alle lernen können, nicht um Strafe.</a:t>
             </a:r>
             <a:endParaRPr lang="en-US" dirty="0"/>
           </a:p>
@@ -1214,7 +1392,7 @@
           <a:p>
             <a:r>
               <a:rPr lang="en-US" dirty="0"/>
-              <a:t>Noten am besten einzeln mitteilen (z. B. während einer Arbeitsphase), nicht im Plenum.</a:t>
+              <a:t>Stufen an die Schulordnung bzw. Absprachen der Klassenleitung anpassen. Die Stufen gelten pro Stunde; wer sich wieder fängt, startet in der nächsten Stunde neu. Wiederholte Störungen fließen in die Einschätzung der Mitarbeit ein, weil sachliche, regelmäßige Mitarbeit dann nicht möglich ist.</a:t>
             </a:r>
             <a:endParaRPr lang="en-US" dirty="0"/>
           </a:p>
@@ -2128,6 +2306,1188 @@
 </p:sld>
 </file>
 
+<file path=ppt/slides/slide10.xml><?xml version="1.0" encoding="utf-8"?>
+<p:sld xmlns:a="http://schemas.openxmlformats.org/drawingml/2006/main" xmlns:r="http://schemas.openxmlformats.org/officeDocument/2006/relationships" xmlns:p="http://schemas.openxmlformats.org/presentationml/2006/main">
+  <p:cSld name="Slide 10">
+    <p:bg>
+      <p:bgPr>
+        <a:solidFill>
+          <a:srgbClr val="FFFFFF"/>
+        </a:solidFill>
+      </p:bgPr>
+    </p:bg>
+    <p:spTree>
+      <p:nvGrpSpPr>
+        <p:cNvPr id="1" name=""/>
+        <p:cNvGrpSpPr/>
+        <p:nvPr/>
+      </p:nvGrpSpPr>
+      <p:grpSpPr>
+        <a:xfrm>
+          <a:off x="0" y="0"/>
+          <a:ext cx="0" cy="0"/>
+          <a:chOff x="0" y="0"/>
+          <a:chExt cx="0" cy="0"/>
+        </a:xfrm>
+      </p:grpSpPr>
+      <p:sp>
+        <p:nvSpPr>
+          <p:cNvPr id="2" name="Text 0"/>
+          <p:cNvSpPr txBox="1"/>
+          <p:nvPr/>
+        </p:nvSpPr>
+        <p:spPr>
+          <a:xfrm>
+            <a:off x="548640" y="365760"/>
+            <a:ext cx="7315200" cy="274320"/>
+          </a:xfrm>
+          <a:prstGeom prst="rect">
+            <a:avLst/>
+          </a:prstGeom>
+          <a:noFill/>
+          <a:ln/>
+        </p:spPr>
+        <p:txBody>
+          <a:bodyPr wrap="square" lIns="0" tIns="0" rIns="0" bIns="0" rtlCol="0" anchor="t"/>
+          <a:lstStyle/>
+          <a:p>
+            <a:pPr indent="0" marL="0">
+              <a:buNone/>
+            </a:pPr>
+            <a:r>
+              <a:rPr lang="en-US" sz="1200" spc="200" kern="0" dirty="0">
+                <a:solidFill>
+                  <a:srgbClr val="5B6B8C"/>
+                </a:solidFill>
+                <a:latin typeface="Calibri" pitchFamily="34" charset="0"/>
+                <a:ea typeface="Calibri" pitchFamily="34" charset="-122"/>
+                <a:cs typeface="Calibri" pitchFamily="34" charset="-120"/>
+              </a:rPr>
+              <a:t>NACH OBEN KOMMEN</a:t>
+            </a:r>
+            <a:endParaRPr lang="en-US" sz="1200" dirty="0"/>
+          </a:p>
+        </p:txBody>
+      </p:sp>
+      <p:sp>
+        <p:nvSpPr>
+          <p:cNvPr id="3" name="Text 1"/>
+          <p:cNvSpPr txBox="1"/>
+          <p:nvPr/>
+        </p:nvSpPr>
+        <p:spPr>
+          <a:xfrm>
+            <a:off x="548640" y="658368"/>
+            <a:ext cx="11064240" cy="640080"/>
+          </a:xfrm>
+          <a:prstGeom prst="rect">
+            <a:avLst/>
+          </a:prstGeom>
+          <a:noFill/>
+          <a:ln/>
+        </p:spPr>
+        <p:txBody>
+          <a:bodyPr wrap="square" lIns="0" tIns="0" rIns="0" bIns="0" rtlCol="0" anchor="t"/>
+          <a:lstStyle/>
+          <a:p>
+            <a:pPr indent="0" marL="0">
+              <a:buNone/>
+            </a:pPr>
+            <a:r>
+              <a:rPr lang="en-US" sz="3200" b="1" dirty="0">
+                <a:solidFill>
+                  <a:srgbClr val="1E2761"/>
+                </a:solidFill>
+                <a:latin typeface="Cambria" pitchFamily="34" charset="0"/>
+                <a:ea typeface="Cambria" pitchFamily="34" charset="-122"/>
+                <a:cs typeface="Cambria" pitchFamily="34" charset="-120"/>
+              </a:rPr>
+              <a:t>So verbesserst du deine mündliche Note</a:t>
+            </a:r>
+            <a:endParaRPr lang="en-US" sz="3200" dirty="0"/>
+          </a:p>
+        </p:txBody>
+      </p:sp>
+      <p:sp>
+        <p:nvSpPr>
+          <p:cNvPr id="4" name="Text 2"/>
+          <p:cNvSpPr txBox="1"/>
+          <p:nvPr/>
+        </p:nvSpPr>
+        <p:spPr>
+          <a:xfrm>
+            <a:off x="548640" y="6400800"/>
+            <a:ext cx="5486400" cy="228600"/>
+          </a:xfrm>
+          <a:prstGeom prst="rect">
+            <a:avLst/>
+          </a:prstGeom>
+          <a:noFill/>
+          <a:ln/>
+        </p:spPr>
+        <p:txBody>
+          <a:bodyPr wrap="square" lIns="0" tIns="0" rIns="0" bIns="0" rtlCol="0" anchor="t"/>
+          <a:lstStyle/>
+          <a:p>
+            <a:pPr indent="0" marL="0">
+              <a:buNone/>
+            </a:pPr>
+            <a:r>
+              <a:rPr lang="en-US" sz="1000" dirty="0">
+                <a:solidFill>
+                  <a:srgbClr val="5B6B8C"/>
+                </a:solidFill>
+                <a:latin typeface="Calibri" pitchFamily="34" charset="0"/>
+                <a:ea typeface="Calibri" pitchFamily="34" charset="-122"/>
+                <a:cs typeface="Calibri" pitchFamily="34" charset="-120"/>
+              </a:rPr>
+              <a:t>Mündliche Noten · Deutsch 7A</a:t>
+            </a:r>
+            <a:endParaRPr lang="en-US" sz="1000" dirty="0"/>
+          </a:p>
+        </p:txBody>
+      </p:sp>
+      <p:sp>
+        <p:nvSpPr>
+          <p:cNvPr id="5" name="Text 3"/>
+          <p:cNvSpPr txBox="1"/>
+          <p:nvPr/>
+        </p:nvSpPr>
+        <p:spPr>
+          <a:xfrm>
+            <a:off x="11155680" y="6400800"/>
+            <a:ext cx="457200" cy="228600"/>
+          </a:xfrm>
+          <a:prstGeom prst="rect">
+            <a:avLst/>
+          </a:prstGeom>
+          <a:noFill/>
+          <a:ln/>
+        </p:spPr>
+        <p:txBody>
+          <a:bodyPr wrap="square" lIns="0" tIns="0" rIns="0" bIns="0" rtlCol="0" anchor="t"/>
+          <a:lstStyle/>
+          <a:p>
+            <a:pPr algn="r" indent="0" marL="0">
+              <a:buNone/>
+            </a:pPr>
+            <a:r>
+              <a:rPr lang="en-US" sz="1000" dirty="0">
+                <a:solidFill>
+                  <a:srgbClr val="5B6B8C"/>
+                </a:solidFill>
+                <a:latin typeface="Calibri" pitchFamily="34" charset="0"/>
+                <a:ea typeface="Calibri" pitchFamily="34" charset="-122"/>
+                <a:cs typeface="Calibri" pitchFamily="34" charset="-120"/>
+              </a:rPr>
+              <a:t>10</a:t>
+            </a:r>
+            <a:endParaRPr lang="en-US" sz="1000" dirty="0"/>
+          </a:p>
+        </p:txBody>
+      </p:sp>
+      <p:sp>
+        <p:nvSpPr>
+          <p:cNvPr id="7" name="Shape 4"/>
+          <p:cNvSpPr/>
+          <p:nvPr/>
+        </p:nvSpPr>
+        <p:spPr>
+          <a:xfrm>
+            <a:off x="548640" y="1673352"/>
+            <a:ext cx="548640" cy="548640"/>
+          </a:xfrm>
+          <a:prstGeom prst="ellipse">
+            <a:avLst/>
+          </a:prstGeom>
+          <a:solidFill>
+            <a:srgbClr val="1E2761"/>
+          </a:solidFill>
+          <a:ln/>
+        </p:spPr>
+      </p:sp>
+      <p:sp>
+        <p:nvSpPr>
+          <p:cNvPr id="8" name="Text 5"/>
+          <p:cNvSpPr txBox="1"/>
+          <p:nvPr/>
+        </p:nvSpPr>
+        <p:spPr>
+          <a:xfrm>
+            <a:off x="548640" y="1673352"/>
+            <a:ext cx="548640" cy="548640"/>
+          </a:xfrm>
+          <a:prstGeom prst="rect">
+            <a:avLst/>
+          </a:prstGeom>
+          <a:noFill/>
+          <a:ln/>
+        </p:spPr>
+        <p:txBody>
+          <a:bodyPr wrap="square" lIns="0" tIns="0" rIns="0" bIns="0" rtlCol="0" anchor="ctr"/>
+          <a:lstStyle/>
+          <a:p>
+            <a:pPr algn="ctr" indent="0" marL="0">
+              <a:buNone/>
+            </a:pPr>
+            <a:r>
+              <a:rPr lang="en-US" sz="1800" b="1" dirty="0">
+                <a:solidFill>
+                  <a:srgbClr val="FFFFFF"/>
+                </a:solidFill>
+                <a:latin typeface="Calibri" pitchFamily="34" charset="0"/>
+                <a:ea typeface="Calibri" pitchFamily="34" charset="-122"/>
+                <a:cs typeface="Calibri" pitchFamily="34" charset="-120"/>
+              </a:rPr>
+              <a:t>1</a:t>
+            </a:r>
+            <a:endParaRPr lang="en-US" sz="1800" dirty="0"/>
+          </a:p>
+        </p:txBody>
+      </p:sp>
+      <p:sp>
+        <p:nvSpPr>
+          <p:cNvPr id="9" name="Text 6"/>
+          <p:cNvSpPr txBox="1"/>
+          <p:nvPr/>
+        </p:nvSpPr>
+        <p:spPr>
+          <a:xfrm>
+            <a:off x="1325880" y="1600200"/>
+            <a:ext cx="10058400" cy="411480"/>
+          </a:xfrm>
+          <a:prstGeom prst="rect">
+            <a:avLst/>
+          </a:prstGeom>
+          <a:noFill/>
+          <a:ln/>
+        </p:spPr>
+        <p:txBody>
+          <a:bodyPr wrap="square" lIns="0" tIns="0" rIns="0" bIns="0" rtlCol="0" anchor="t"/>
+          <a:lstStyle/>
+          <a:p>
+            <a:pPr indent="0" marL="0">
+              <a:buNone/>
+            </a:pPr>
+            <a:r>
+              <a:rPr lang="en-US" sz="2100" b="1" dirty="0">
+                <a:solidFill>
+                  <a:srgbClr val="1E2761"/>
+                </a:solidFill>
+                <a:latin typeface="Cambria" pitchFamily="34" charset="0"/>
+                <a:ea typeface="Cambria" pitchFamily="34" charset="-122"/>
+                <a:cs typeface="Cambria" pitchFamily="34" charset="-120"/>
+              </a:rPr>
+              <a:t>Melde dich auch, wenn du unsicher bist.</a:t>
+            </a:r>
+            <a:endParaRPr lang="en-US" sz="2100" dirty="0"/>
+          </a:p>
+        </p:txBody>
+      </p:sp>
+      <p:sp>
+        <p:nvSpPr>
+          <p:cNvPr id="10" name="Text 7"/>
+          <p:cNvSpPr txBox="1"/>
+          <p:nvPr/>
+        </p:nvSpPr>
+        <p:spPr>
+          <a:xfrm>
+            <a:off x="1325880" y="2011680"/>
+            <a:ext cx="10058400" cy="365760"/>
+          </a:xfrm>
+          <a:prstGeom prst="rect">
+            <a:avLst/>
+          </a:prstGeom>
+          <a:noFill/>
+          <a:ln/>
+        </p:spPr>
+        <p:txBody>
+          <a:bodyPr wrap="square" lIns="0" tIns="0" rIns="0" bIns="0" rtlCol="0" anchor="t"/>
+          <a:lstStyle/>
+          <a:p>
+            <a:pPr indent="0" marL="0">
+              <a:buNone/>
+            </a:pPr>
+            <a:r>
+              <a:rPr lang="en-US" sz="1600" dirty="0">
+                <a:solidFill>
+                  <a:srgbClr val="5B6B8C"/>
+                </a:solidFill>
+                <a:latin typeface="Calibri" pitchFamily="34" charset="0"/>
+                <a:ea typeface="Calibri" pitchFamily="34" charset="-122"/>
+                <a:cs typeface="Calibri" pitchFamily="34" charset="-120"/>
+              </a:rPr>
+              <a:t>Ein Fehler zählt nicht gegen dich – keine Mitarbeit schon.</a:t>
+            </a:r>
+            <a:endParaRPr lang="en-US" sz="1600" dirty="0"/>
+          </a:p>
+        </p:txBody>
+      </p:sp>
+      <p:sp>
+        <p:nvSpPr>
+          <p:cNvPr id="11" name="Shape 8"/>
+          <p:cNvSpPr/>
+          <p:nvPr/>
+        </p:nvSpPr>
+        <p:spPr>
+          <a:xfrm>
+            <a:off x="548640" y="2587752"/>
+            <a:ext cx="548640" cy="548640"/>
+          </a:xfrm>
+          <a:prstGeom prst="ellipse">
+            <a:avLst/>
+          </a:prstGeom>
+          <a:solidFill>
+            <a:srgbClr val="1E2761"/>
+          </a:solidFill>
+          <a:ln/>
+        </p:spPr>
+      </p:sp>
+      <p:sp>
+        <p:nvSpPr>
+          <p:cNvPr id="12" name="Text 9"/>
+          <p:cNvSpPr txBox="1"/>
+          <p:nvPr/>
+        </p:nvSpPr>
+        <p:spPr>
+          <a:xfrm>
+            <a:off x="548640" y="2587752"/>
+            <a:ext cx="548640" cy="548640"/>
+          </a:xfrm>
+          <a:prstGeom prst="rect">
+            <a:avLst/>
+          </a:prstGeom>
+          <a:noFill/>
+          <a:ln/>
+        </p:spPr>
+        <p:txBody>
+          <a:bodyPr wrap="square" lIns="0" tIns="0" rIns="0" bIns="0" rtlCol="0" anchor="ctr"/>
+          <a:lstStyle/>
+          <a:p>
+            <a:pPr algn="ctr" indent="0" marL="0">
+              <a:buNone/>
+            </a:pPr>
+            <a:r>
+              <a:rPr lang="en-US" sz="1800" b="1" dirty="0">
+                <a:solidFill>
+                  <a:srgbClr val="FFFFFF"/>
+                </a:solidFill>
+                <a:latin typeface="Calibri" pitchFamily="34" charset="0"/>
+                <a:ea typeface="Calibri" pitchFamily="34" charset="-122"/>
+                <a:cs typeface="Calibri" pitchFamily="34" charset="-120"/>
+              </a:rPr>
+              <a:t>2</a:t>
+            </a:r>
+            <a:endParaRPr lang="en-US" sz="1800" dirty="0"/>
+          </a:p>
+        </p:txBody>
+      </p:sp>
+      <p:sp>
+        <p:nvSpPr>
+          <p:cNvPr id="13" name="Text 10"/>
+          <p:cNvSpPr txBox="1"/>
+          <p:nvPr/>
+        </p:nvSpPr>
+        <p:spPr>
+          <a:xfrm>
+            <a:off x="1325880" y="2514600"/>
+            <a:ext cx="10058400" cy="411480"/>
+          </a:xfrm>
+          <a:prstGeom prst="rect">
+            <a:avLst/>
+          </a:prstGeom>
+          <a:noFill/>
+          <a:ln/>
+        </p:spPr>
+        <p:txBody>
+          <a:bodyPr wrap="square" lIns="0" tIns="0" rIns="0" bIns="0" rtlCol="0" anchor="t"/>
+          <a:lstStyle/>
+          <a:p>
+            <a:pPr indent="0" marL="0">
+              <a:buNone/>
+            </a:pPr>
+            <a:r>
+              <a:rPr lang="en-US" sz="2100" b="1" dirty="0">
+                <a:solidFill>
+                  <a:srgbClr val="1E2761"/>
+                </a:solidFill>
+                <a:latin typeface="Cambria" pitchFamily="34" charset="0"/>
+                <a:ea typeface="Cambria" pitchFamily="34" charset="-122"/>
+                <a:cs typeface="Cambria" pitchFamily="34" charset="-120"/>
+              </a:rPr>
+              <a:t>Benutze Fachbegriffe.</a:t>
+            </a:r>
+            <a:endParaRPr lang="en-US" sz="2100" dirty="0"/>
+          </a:p>
+        </p:txBody>
+      </p:sp>
+      <p:sp>
+        <p:nvSpPr>
+          <p:cNvPr id="14" name="Text 11"/>
+          <p:cNvSpPr txBox="1"/>
+          <p:nvPr/>
+        </p:nvSpPr>
+        <p:spPr>
+          <a:xfrm>
+            <a:off x="1325880" y="2926080"/>
+            <a:ext cx="10058400" cy="365760"/>
+          </a:xfrm>
+          <a:prstGeom prst="rect">
+            <a:avLst/>
+          </a:prstGeom>
+          <a:noFill/>
+          <a:ln/>
+        </p:spPr>
+        <p:txBody>
+          <a:bodyPr wrap="square" lIns="0" tIns="0" rIns="0" bIns="0" rtlCol="0" anchor="t"/>
+          <a:lstStyle/>
+          <a:p>
+            <a:pPr indent="0" marL="0">
+              <a:buNone/>
+            </a:pPr>
+            <a:r>
+              <a:rPr lang="en-US" sz="1600" dirty="0">
+                <a:solidFill>
+                  <a:srgbClr val="5B6B8C"/>
+                </a:solidFill>
+                <a:latin typeface="Calibri" pitchFamily="34" charset="0"/>
+                <a:ea typeface="Calibri" pitchFamily="34" charset="-122"/>
+                <a:cs typeface="Calibri" pitchFamily="34" charset="-120"/>
+              </a:rPr>
+              <a:t>Finite Form, Partizip II, Strophe, Vers … statt „das Wort da“.</a:t>
+            </a:r>
+            <a:endParaRPr lang="en-US" sz="1600" dirty="0"/>
+          </a:p>
+        </p:txBody>
+      </p:sp>
+      <p:sp>
+        <p:nvSpPr>
+          <p:cNvPr id="15" name="Shape 12"/>
+          <p:cNvSpPr/>
+          <p:nvPr/>
+        </p:nvSpPr>
+        <p:spPr>
+          <a:xfrm>
+            <a:off x="548640" y="3502152"/>
+            <a:ext cx="548640" cy="548640"/>
+          </a:xfrm>
+          <a:prstGeom prst="ellipse">
+            <a:avLst/>
+          </a:prstGeom>
+          <a:solidFill>
+            <a:srgbClr val="1E2761"/>
+          </a:solidFill>
+          <a:ln/>
+        </p:spPr>
+      </p:sp>
+      <p:sp>
+        <p:nvSpPr>
+          <p:cNvPr id="16" name="Text 13"/>
+          <p:cNvSpPr txBox="1"/>
+          <p:nvPr/>
+        </p:nvSpPr>
+        <p:spPr>
+          <a:xfrm>
+            <a:off x="548640" y="3502152"/>
+            <a:ext cx="548640" cy="548640"/>
+          </a:xfrm>
+          <a:prstGeom prst="rect">
+            <a:avLst/>
+          </a:prstGeom>
+          <a:noFill/>
+          <a:ln/>
+        </p:spPr>
+        <p:txBody>
+          <a:bodyPr wrap="square" lIns="0" tIns="0" rIns="0" bIns="0" rtlCol="0" anchor="ctr"/>
+          <a:lstStyle/>
+          <a:p>
+            <a:pPr algn="ctr" indent="0" marL="0">
+              <a:buNone/>
+            </a:pPr>
+            <a:r>
+              <a:rPr lang="en-US" sz="1800" b="1" dirty="0">
+                <a:solidFill>
+                  <a:srgbClr val="FFFFFF"/>
+                </a:solidFill>
+                <a:latin typeface="Calibri" pitchFamily="34" charset="0"/>
+                <a:ea typeface="Calibri" pitchFamily="34" charset="-122"/>
+                <a:cs typeface="Calibri" pitchFamily="34" charset="-120"/>
+              </a:rPr>
+              <a:t>3</a:t>
+            </a:r>
+            <a:endParaRPr lang="en-US" sz="1800" dirty="0"/>
+          </a:p>
+        </p:txBody>
+      </p:sp>
+      <p:sp>
+        <p:nvSpPr>
+          <p:cNvPr id="17" name="Text 14"/>
+          <p:cNvSpPr txBox="1"/>
+          <p:nvPr/>
+        </p:nvSpPr>
+        <p:spPr>
+          <a:xfrm>
+            <a:off x="1325880" y="3429000"/>
+            <a:ext cx="10058400" cy="411480"/>
+          </a:xfrm>
+          <a:prstGeom prst="rect">
+            <a:avLst/>
+          </a:prstGeom>
+          <a:noFill/>
+          <a:ln/>
+        </p:spPr>
+        <p:txBody>
+          <a:bodyPr wrap="square" lIns="0" tIns="0" rIns="0" bIns="0" rtlCol="0" anchor="t"/>
+          <a:lstStyle/>
+          <a:p>
+            <a:pPr indent="0" marL="0">
+              <a:buNone/>
+            </a:pPr>
+            <a:r>
+              <a:rPr lang="en-US" sz="2100" b="1" dirty="0">
+                <a:solidFill>
+                  <a:srgbClr val="1E2761"/>
+                </a:solidFill>
+                <a:latin typeface="Cambria" pitchFamily="34" charset="0"/>
+                <a:ea typeface="Cambria" pitchFamily="34" charset="-122"/>
+                <a:cs typeface="Cambria" pitchFamily="34" charset="-120"/>
+              </a:rPr>
+              <a:t>Begründe mit „weil“.</a:t>
+            </a:r>
+            <a:endParaRPr lang="en-US" sz="2100" dirty="0"/>
+          </a:p>
+        </p:txBody>
+      </p:sp>
+      <p:sp>
+        <p:nvSpPr>
+          <p:cNvPr id="18" name="Text 15"/>
+          <p:cNvSpPr txBox="1"/>
+          <p:nvPr/>
+        </p:nvSpPr>
+        <p:spPr>
+          <a:xfrm>
+            <a:off x="1325880" y="3840480"/>
+            <a:ext cx="10058400" cy="365760"/>
+          </a:xfrm>
+          <a:prstGeom prst="rect">
+            <a:avLst/>
+          </a:prstGeom>
+          <a:noFill/>
+          <a:ln/>
+        </p:spPr>
+        <p:txBody>
+          <a:bodyPr wrap="square" lIns="0" tIns="0" rIns="0" bIns="0" rtlCol="0" anchor="t"/>
+          <a:lstStyle/>
+          <a:p>
+            <a:pPr indent="0" marL="0">
+              <a:buNone/>
+            </a:pPr>
+            <a:r>
+              <a:rPr lang="en-US" sz="1600" dirty="0">
+                <a:solidFill>
+                  <a:srgbClr val="5B6B8C"/>
+                </a:solidFill>
+                <a:latin typeface="Calibri" pitchFamily="34" charset="0"/>
+                <a:ea typeface="Calibri" pitchFamily="34" charset="-122"/>
+                <a:cs typeface="Calibri" pitchFamily="34" charset="-120"/>
+              </a:rPr>
+              <a:t>Eine Antwort mit Begründung ist mehr wert als ein einzelnes Wort.</a:t>
+            </a:r>
+            <a:endParaRPr lang="en-US" sz="1600" dirty="0"/>
+          </a:p>
+        </p:txBody>
+      </p:sp>
+      <p:sp>
+        <p:nvSpPr>
+          <p:cNvPr id="19" name="Shape 16"/>
+          <p:cNvSpPr/>
+          <p:nvPr/>
+        </p:nvSpPr>
+        <p:spPr>
+          <a:xfrm>
+            <a:off x="548640" y="4416552"/>
+            <a:ext cx="548640" cy="548640"/>
+          </a:xfrm>
+          <a:prstGeom prst="ellipse">
+            <a:avLst/>
+          </a:prstGeom>
+          <a:solidFill>
+            <a:srgbClr val="1E2761"/>
+          </a:solidFill>
+          <a:ln/>
+        </p:spPr>
+      </p:sp>
+      <p:sp>
+        <p:nvSpPr>
+          <p:cNvPr id="20" name="Text 17"/>
+          <p:cNvSpPr txBox="1"/>
+          <p:nvPr/>
+        </p:nvSpPr>
+        <p:spPr>
+          <a:xfrm>
+            <a:off x="548640" y="4416552"/>
+            <a:ext cx="548640" cy="548640"/>
+          </a:xfrm>
+          <a:prstGeom prst="rect">
+            <a:avLst/>
+          </a:prstGeom>
+          <a:noFill/>
+          <a:ln/>
+        </p:spPr>
+        <p:txBody>
+          <a:bodyPr wrap="square" lIns="0" tIns="0" rIns="0" bIns="0" rtlCol="0" anchor="ctr"/>
+          <a:lstStyle/>
+          <a:p>
+            <a:pPr algn="ctr" indent="0" marL="0">
+              <a:buNone/>
+            </a:pPr>
+            <a:r>
+              <a:rPr lang="en-US" sz="1800" b="1" dirty="0">
+                <a:solidFill>
+                  <a:srgbClr val="FFFFFF"/>
+                </a:solidFill>
+                <a:latin typeface="Calibri" pitchFamily="34" charset="0"/>
+                <a:ea typeface="Calibri" pitchFamily="34" charset="-122"/>
+                <a:cs typeface="Calibri" pitchFamily="34" charset="-120"/>
+              </a:rPr>
+              <a:t>4</a:t>
+            </a:r>
+            <a:endParaRPr lang="en-US" sz="1800" dirty="0"/>
+          </a:p>
+        </p:txBody>
+      </p:sp>
+      <p:sp>
+        <p:nvSpPr>
+          <p:cNvPr id="21" name="Text 18"/>
+          <p:cNvSpPr txBox="1"/>
+          <p:nvPr/>
+        </p:nvSpPr>
+        <p:spPr>
+          <a:xfrm>
+            <a:off x="1325880" y="4343400"/>
+            <a:ext cx="10058400" cy="411480"/>
+          </a:xfrm>
+          <a:prstGeom prst="rect">
+            <a:avLst/>
+          </a:prstGeom>
+          <a:noFill/>
+          <a:ln/>
+        </p:spPr>
+        <p:txBody>
+          <a:bodyPr wrap="square" lIns="0" tIns="0" rIns="0" bIns="0" rtlCol="0" anchor="t"/>
+          <a:lstStyle/>
+          <a:p>
+            <a:pPr indent="0" marL="0">
+              <a:buNone/>
+            </a:pPr>
+            <a:r>
+              <a:rPr lang="en-US" sz="2100" b="1" dirty="0">
+                <a:solidFill>
+                  <a:srgbClr val="1E2761"/>
+                </a:solidFill>
+                <a:latin typeface="Cambria" pitchFamily="34" charset="0"/>
+                <a:ea typeface="Cambria" pitchFamily="34" charset="-122"/>
+                <a:cs typeface="Cambria" pitchFamily="34" charset="-120"/>
+              </a:rPr>
+              <a:t>Verknüpfe mit früheren Stunden.</a:t>
+            </a:r>
+            <a:endParaRPr lang="en-US" sz="2100" dirty="0"/>
+          </a:p>
+        </p:txBody>
+      </p:sp>
+      <p:sp>
+        <p:nvSpPr>
+          <p:cNvPr id="22" name="Text 19"/>
+          <p:cNvSpPr txBox="1"/>
+          <p:nvPr/>
+        </p:nvSpPr>
+        <p:spPr>
+          <a:xfrm>
+            <a:off x="1325880" y="4754880"/>
+            <a:ext cx="10058400" cy="365760"/>
+          </a:xfrm>
+          <a:prstGeom prst="rect">
+            <a:avLst/>
+          </a:prstGeom>
+          <a:noFill/>
+          <a:ln/>
+        </p:spPr>
+        <p:txBody>
+          <a:bodyPr wrap="square" lIns="0" tIns="0" rIns="0" bIns="0" rtlCol="0" anchor="t"/>
+          <a:lstStyle/>
+          <a:p>
+            <a:pPr indent="0" marL="0">
+              <a:buNone/>
+            </a:pPr>
+            <a:r>
+              <a:rPr lang="en-US" sz="1600" dirty="0">
+                <a:solidFill>
+                  <a:srgbClr val="5B6B8C"/>
+                </a:solidFill>
+                <a:latin typeface="Calibri" pitchFamily="34" charset="0"/>
+                <a:ea typeface="Calibri" pitchFamily="34" charset="-122"/>
+                <a:cs typeface="Calibri" pitchFamily="34" charset="-120"/>
+              </a:rPr>
+              <a:t>„Das ist wie beim …“ – genau das macht den Unterschied zwischen 4 und 3.</a:t>
+            </a:r>
+            <a:endParaRPr lang="en-US" sz="1600" dirty="0"/>
+          </a:p>
+        </p:txBody>
+      </p:sp>
+      <p:sp>
+        <p:nvSpPr>
+          <p:cNvPr id="23" name="Shape 20"/>
+          <p:cNvSpPr/>
+          <p:nvPr/>
+        </p:nvSpPr>
+        <p:spPr>
+          <a:xfrm>
+            <a:off x="548640" y="5330952"/>
+            <a:ext cx="548640" cy="548640"/>
+          </a:xfrm>
+          <a:prstGeom prst="ellipse">
+            <a:avLst/>
+          </a:prstGeom>
+          <a:solidFill>
+            <a:srgbClr val="1E2761"/>
+          </a:solidFill>
+          <a:ln/>
+        </p:spPr>
+      </p:sp>
+      <p:sp>
+        <p:nvSpPr>
+          <p:cNvPr id="24" name="Text 21"/>
+          <p:cNvSpPr txBox="1"/>
+          <p:nvPr/>
+        </p:nvSpPr>
+        <p:spPr>
+          <a:xfrm>
+            <a:off x="548640" y="5330952"/>
+            <a:ext cx="548640" cy="548640"/>
+          </a:xfrm>
+          <a:prstGeom prst="rect">
+            <a:avLst/>
+          </a:prstGeom>
+          <a:noFill/>
+          <a:ln/>
+        </p:spPr>
+        <p:txBody>
+          <a:bodyPr wrap="square" lIns="0" tIns="0" rIns="0" bIns="0" rtlCol="0" anchor="ctr"/>
+          <a:lstStyle/>
+          <a:p>
+            <a:pPr algn="ctr" indent="0" marL="0">
+              <a:buNone/>
+            </a:pPr>
+            <a:r>
+              <a:rPr lang="en-US" sz="1800" b="1" dirty="0">
+                <a:solidFill>
+                  <a:srgbClr val="FFFFFF"/>
+                </a:solidFill>
+                <a:latin typeface="Calibri" pitchFamily="34" charset="0"/>
+                <a:ea typeface="Calibri" pitchFamily="34" charset="-122"/>
+                <a:cs typeface="Calibri" pitchFamily="34" charset="-120"/>
+              </a:rPr>
+              <a:t>5</a:t>
+            </a:r>
+            <a:endParaRPr lang="en-US" sz="1800" dirty="0"/>
+          </a:p>
+        </p:txBody>
+      </p:sp>
+      <p:sp>
+        <p:nvSpPr>
+          <p:cNvPr id="25" name="Text 22"/>
+          <p:cNvSpPr txBox="1"/>
+          <p:nvPr/>
+        </p:nvSpPr>
+        <p:spPr>
+          <a:xfrm>
+            <a:off x="1325880" y="5257800"/>
+            <a:ext cx="10058400" cy="411480"/>
+          </a:xfrm>
+          <a:prstGeom prst="rect">
+            <a:avLst/>
+          </a:prstGeom>
+          <a:noFill/>
+          <a:ln/>
+        </p:spPr>
+        <p:txBody>
+          <a:bodyPr wrap="square" lIns="0" tIns="0" rIns="0" bIns="0" rtlCol="0" anchor="t"/>
+          <a:lstStyle/>
+          <a:p>
+            <a:pPr indent="0" marL="0">
+              <a:buNone/>
+            </a:pPr>
+            <a:r>
+              <a:rPr lang="en-US" sz="2100" b="1" dirty="0">
+                <a:solidFill>
+                  <a:srgbClr val="1E2761"/>
+                </a:solidFill>
+                <a:latin typeface="Cambria" pitchFamily="34" charset="0"/>
+                <a:ea typeface="Cambria" pitchFamily="34" charset="-122"/>
+                <a:cs typeface="Cambria" pitchFamily="34" charset="-120"/>
+              </a:rPr>
+              <a:t>Hör zu und knüpf an.</a:t>
+            </a:r>
+            <a:endParaRPr lang="en-US" sz="2100" dirty="0"/>
+          </a:p>
+        </p:txBody>
+      </p:sp>
+      <p:sp>
+        <p:nvSpPr>
+          <p:cNvPr id="26" name="Text 23"/>
+          <p:cNvSpPr txBox="1"/>
+          <p:nvPr/>
+        </p:nvSpPr>
+        <p:spPr>
+          <a:xfrm>
+            <a:off x="1325880" y="5669280"/>
+            <a:ext cx="10058400" cy="365760"/>
+          </a:xfrm>
+          <a:prstGeom prst="rect">
+            <a:avLst/>
+          </a:prstGeom>
+          <a:noFill/>
+          <a:ln/>
+        </p:spPr>
+        <p:txBody>
+          <a:bodyPr wrap="square" lIns="0" tIns="0" rIns="0" bIns="0" rtlCol="0" anchor="t"/>
+          <a:lstStyle/>
+          <a:p>
+            <a:pPr indent="0" marL="0">
+              <a:buNone/>
+            </a:pPr>
+            <a:r>
+              <a:rPr lang="en-US" sz="1600" dirty="0">
+                <a:solidFill>
+                  <a:srgbClr val="5B6B8C"/>
+                </a:solidFill>
+                <a:latin typeface="Calibri" pitchFamily="34" charset="0"/>
+                <a:ea typeface="Calibri" pitchFamily="34" charset="-122"/>
+                <a:cs typeface="Calibri" pitchFamily="34" charset="-120"/>
+              </a:rPr>
+              <a:t>„Ich ergänze zu …“ oder „Ich sehe das anders, weil …“</a:t>
+            </a:r>
+            <a:endParaRPr lang="en-US" sz="1600" dirty="0"/>
+          </a:p>
+        </p:txBody>
+      </p:sp>
+    </p:spTree>
+  </p:cSld>
+  <p:clrMapOvr>
+    <a:masterClrMapping/>
+  </p:clrMapOvr>
+</p:sld>
+</file>
+
+<file path=ppt/slides/slide11.xml><?xml version="1.0" encoding="utf-8"?>
+<p:sld xmlns:a="http://schemas.openxmlformats.org/drawingml/2006/main" xmlns:r="http://schemas.openxmlformats.org/officeDocument/2006/relationships" xmlns:p="http://schemas.openxmlformats.org/presentationml/2006/main">
+  <p:cSld name="Slide 11">
+    <p:bg>
+      <p:bgPr>
+        <a:solidFill>
+          <a:srgbClr val="1E2761"/>
+        </a:solidFill>
+      </p:bgPr>
+    </p:bg>
+    <p:spTree>
+      <p:nvGrpSpPr>
+        <p:cNvPr id="1" name=""/>
+        <p:cNvGrpSpPr/>
+        <p:nvPr/>
+      </p:nvGrpSpPr>
+      <p:grpSpPr>
+        <a:xfrm>
+          <a:off x="0" y="0"/>
+          <a:ext cx="0" cy="0"/>
+          <a:chOff x="0" y="0"/>
+          <a:chExt cx="0" cy="0"/>
+        </a:xfrm>
+      </p:grpSpPr>
+      <p:sp>
+        <p:nvSpPr>
+          <p:cNvPr id="2" name="Shape 0"/>
+          <p:cNvSpPr/>
+          <p:nvPr/>
+        </p:nvSpPr>
+        <p:spPr>
+          <a:xfrm>
+            <a:off x="9692640" y="-1463040"/>
+            <a:ext cx="4206240" cy="4206240"/>
+          </a:xfrm>
+          <a:prstGeom prst="ellipse">
+            <a:avLst/>
+          </a:prstGeom>
+          <a:solidFill>
+            <a:srgbClr val="24306E"/>
+          </a:solidFill>
+          <a:ln/>
+        </p:spPr>
+      </p:sp>
+      <p:sp>
+        <p:nvSpPr>
+          <p:cNvPr id="3" name="Shape 1"/>
+          <p:cNvSpPr/>
+          <p:nvPr/>
+        </p:nvSpPr>
+        <p:spPr>
+          <a:xfrm>
+            <a:off x="-1371600" y="4206240"/>
+            <a:ext cx="3657600" cy="3657600"/>
+          </a:xfrm>
+          <a:prstGeom prst="ellipse">
+            <a:avLst/>
+          </a:prstGeom>
+          <a:solidFill>
+            <a:srgbClr val="24306E"/>
+          </a:solidFill>
+          <a:ln/>
+        </p:spPr>
+      </p:sp>
+      <p:sp>
+        <p:nvSpPr>
+          <p:cNvPr id="4" name="Text 2"/>
+          <p:cNvSpPr txBox="1"/>
+          <p:nvPr/>
+        </p:nvSpPr>
+        <p:spPr>
+          <a:xfrm>
+            <a:off x="822960" y="1737360"/>
+            <a:ext cx="10058400" cy="822960"/>
+          </a:xfrm>
+          <a:prstGeom prst="rect">
+            <a:avLst/>
+          </a:prstGeom>
+          <a:noFill/>
+          <a:ln/>
+        </p:spPr>
+        <p:txBody>
+          <a:bodyPr wrap="square" lIns="0" tIns="0" rIns="0" bIns="0" rtlCol="0" anchor="t"/>
+          <a:lstStyle/>
+          <a:p>
+            <a:pPr indent="0" marL="0">
+              <a:buNone/>
+            </a:pPr>
+            <a:r>
+              <a:rPr lang="en-US" sz="4000" b="1" dirty="0">
+                <a:solidFill>
+                  <a:srgbClr val="FFFFFF"/>
+                </a:solidFill>
+                <a:latin typeface="Cambria" pitchFamily="34" charset="0"/>
+                <a:ea typeface="Cambria" pitchFamily="34" charset="-122"/>
+                <a:cs typeface="Cambria" pitchFamily="34" charset="-120"/>
+              </a:rPr>
+              <a:t>Und jetzt?</a:t>
+            </a:r>
+            <a:endParaRPr lang="en-US" sz="4000" dirty="0"/>
+          </a:p>
+        </p:txBody>
+      </p:sp>
+      <p:sp>
+        <p:nvSpPr>
+          <p:cNvPr id="5" name="Text 3"/>
+          <p:cNvSpPr txBox="1"/>
+          <p:nvPr/>
+        </p:nvSpPr>
+        <p:spPr>
+          <a:xfrm>
+            <a:off x="822960" y="2834640"/>
+            <a:ext cx="10515600" cy="640080"/>
+          </a:xfrm>
+          <a:prstGeom prst="rect">
+            <a:avLst/>
+          </a:prstGeom>
+          <a:noFill/>
+          <a:ln/>
+        </p:spPr>
+        <p:txBody>
+          <a:bodyPr wrap="square" lIns="0" tIns="0" rIns="0" bIns="0" rtlCol="0" anchor="t"/>
+          <a:lstStyle/>
+          <a:p>
+            <a:pPr indent="0" marL="0">
+              <a:buNone/>
+            </a:pPr>
+            <a:r>
+              <a:rPr lang="en-US" sz="2200" b="1" dirty="0">
+                <a:solidFill>
+                  <a:srgbClr val="E8A33D"/>
+                </a:solidFill>
+                <a:latin typeface="Calibri" pitchFamily="34" charset="0"/>
+                <a:ea typeface="Calibri" pitchFamily="34" charset="-122"/>
+                <a:cs typeface="Calibri" pitchFamily="34" charset="-120"/>
+              </a:rPr>
+              <a:t>1  </a:t>
+            </a:r>
+            <a:pPr indent="0" marL="0">
+              <a:buNone/>
+            </a:pPr>
+            <a:r>
+              <a:rPr lang="en-US" sz="2200" dirty="0">
+                <a:solidFill>
+                  <a:srgbClr val="FFFFFF"/>
+                </a:solidFill>
+                <a:latin typeface="Calibri" pitchFamily="34" charset="0"/>
+                <a:ea typeface="Calibri" pitchFamily="34" charset="-122"/>
+                <a:cs typeface="Calibri" pitchFamily="34" charset="-120"/>
+              </a:rPr>
+              <a:t>Ich teile dir deine aktuelle mündliche Note mit – mit einer kurzen Begründung.</a:t>
+            </a:r>
+            <a:endParaRPr lang="en-US" sz="2200" dirty="0"/>
+          </a:p>
+        </p:txBody>
+      </p:sp>
+      <p:sp>
+        <p:nvSpPr>
+          <p:cNvPr id="6" name="Text 4"/>
+          <p:cNvSpPr txBox="1"/>
+          <p:nvPr/>
+        </p:nvSpPr>
+        <p:spPr>
+          <a:xfrm>
+            <a:off x="822960" y="3611880"/>
+            <a:ext cx="10515600" cy="640080"/>
+          </a:xfrm>
+          <a:prstGeom prst="rect">
+            <a:avLst/>
+          </a:prstGeom>
+          <a:noFill/>
+          <a:ln/>
+        </p:spPr>
+        <p:txBody>
+          <a:bodyPr wrap="square" lIns="0" tIns="0" rIns="0" bIns="0" rtlCol="0" anchor="t"/>
+          <a:lstStyle/>
+          <a:p>
+            <a:pPr indent="0" marL="0">
+              <a:buNone/>
+            </a:pPr>
+            <a:r>
+              <a:rPr lang="en-US" sz="2200" b="1" dirty="0">
+                <a:solidFill>
+                  <a:srgbClr val="E8A33D"/>
+                </a:solidFill>
+                <a:latin typeface="Calibri" pitchFamily="34" charset="0"/>
+                <a:ea typeface="Calibri" pitchFamily="34" charset="-122"/>
+                <a:cs typeface="Calibri" pitchFamily="34" charset="-120"/>
+              </a:rPr>
+              <a:t>2  </a:t>
+            </a:r>
+            <a:pPr indent="0" marL="0">
+              <a:buNone/>
+            </a:pPr>
+            <a:r>
+              <a:rPr lang="en-US" sz="2200" dirty="0">
+                <a:solidFill>
+                  <a:srgbClr val="FFFFFF"/>
+                </a:solidFill>
+                <a:latin typeface="Calibri" pitchFamily="34" charset="0"/>
+                <a:ea typeface="Calibri" pitchFamily="34" charset="-122"/>
+                <a:cs typeface="Calibri" pitchFamily="34" charset="-120"/>
+              </a:rPr>
+              <a:t>Überleg dir: Welche Stufe willst du bis Weihnachten erreichen?</a:t>
+            </a:r>
+            <a:endParaRPr lang="en-US" sz="2200" dirty="0"/>
+          </a:p>
+        </p:txBody>
+      </p:sp>
+      <p:sp>
+        <p:nvSpPr>
+          <p:cNvPr id="7" name="Text 5"/>
+          <p:cNvSpPr txBox="1"/>
+          <p:nvPr/>
+        </p:nvSpPr>
+        <p:spPr>
+          <a:xfrm>
+            <a:off x="822960" y="4389120"/>
+            <a:ext cx="10515600" cy="640080"/>
+          </a:xfrm>
+          <a:prstGeom prst="rect">
+            <a:avLst/>
+          </a:prstGeom>
+          <a:noFill/>
+          <a:ln/>
+        </p:spPr>
+        <p:txBody>
+          <a:bodyPr wrap="square" lIns="0" tIns="0" rIns="0" bIns="0" rtlCol="0" anchor="t"/>
+          <a:lstStyle/>
+          <a:p>
+            <a:pPr indent="0" marL="0">
+              <a:buNone/>
+            </a:pPr>
+            <a:r>
+              <a:rPr lang="en-US" sz="2200" b="1" dirty="0">
+                <a:solidFill>
+                  <a:srgbClr val="E8A33D"/>
+                </a:solidFill>
+                <a:latin typeface="Calibri" pitchFamily="34" charset="0"/>
+                <a:ea typeface="Calibri" pitchFamily="34" charset="-122"/>
+                <a:cs typeface="Calibri" pitchFamily="34" charset="-120"/>
+              </a:rPr>
+              <a:t>3  </a:t>
+            </a:r>
+            <a:pPr indent="0" marL="0">
+              <a:buNone/>
+            </a:pPr>
+            <a:r>
+              <a:rPr lang="en-US" sz="2200" dirty="0">
+                <a:solidFill>
+                  <a:srgbClr val="FFFFFF"/>
+                </a:solidFill>
+                <a:latin typeface="Calibri" pitchFamily="34" charset="0"/>
+                <a:ea typeface="Calibri" pitchFamily="34" charset="-122"/>
+                <a:cs typeface="Calibri" pitchFamily="34" charset="-120"/>
+              </a:rPr>
+              <a:t>Schreib einen Tipp ins Heft, an dem du arbeitest – und was du gegen Störungen tust.</a:t>
+            </a:r>
+            <a:endParaRPr lang="en-US" sz="2200" dirty="0"/>
+          </a:p>
+        </p:txBody>
+      </p:sp>
+      <p:sp>
+        <p:nvSpPr>
+          <p:cNvPr id="8" name="Text 6"/>
+          <p:cNvSpPr txBox="1"/>
+          <p:nvPr/>
+        </p:nvSpPr>
+        <p:spPr>
+          <a:xfrm>
+            <a:off x="822960" y="6217920"/>
+            <a:ext cx="10058400" cy="274320"/>
+          </a:xfrm>
+          <a:prstGeom prst="rect">
+            <a:avLst/>
+          </a:prstGeom>
+          <a:noFill/>
+          <a:ln/>
+        </p:spPr>
+        <p:txBody>
+          <a:bodyPr wrap="square" lIns="0" tIns="0" rIns="0" bIns="0" rtlCol="0" anchor="t"/>
+          <a:lstStyle/>
+          <a:p>
+            <a:pPr indent="0" marL="0">
+              <a:buNone/>
+            </a:pPr>
+            <a:r>
+              <a:rPr lang="en-US" sz="1100" dirty="0">
+                <a:solidFill>
+                  <a:srgbClr val="CADCFC"/>
+                </a:solidFill>
+                <a:latin typeface="Calibri" pitchFamily="34" charset="0"/>
+                <a:ea typeface="Calibri" pitchFamily="34" charset="-122"/>
+                <a:cs typeface="Calibri" pitchFamily="34" charset="-120"/>
+              </a:rPr>
+              <a:t>Grundlage: Kriterien zur Beurteilung der mündlichen Leistung (lehrerfreund.de)</a:t>
+            </a:r>
+            <a:endParaRPr lang="en-US" sz="1100" dirty="0"/>
+          </a:p>
+        </p:txBody>
+      </p:sp>
+    </p:spTree>
+  </p:cSld>
+  <p:clrMapOvr>
+    <a:masterClrMapping/>
+  </p:clrMapOvr>
+</p:sld>
+</file>
+
 <file path=ppt/slides/slide2.xml><?xml version="1.0" encoding="utf-8"?>
 <p:sld xmlns:a="http://schemas.openxmlformats.org/drawingml/2006/main" xmlns:r="http://schemas.openxmlformats.org/officeDocument/2006/relationships" xmlns:p="http://schemas.openxmlformats.org/presentationml/2006/main">
   <p:cSld name="Slide 2">
@@ -6630,7 +7990,7 @@
                 <a:ea typeface="Calibri" pitchFamily="34" charset="-122"/>
                 <a:cs typeface="Calibri" pitchFamily="34" charset="-120"/>
               </a:rPr>
-              <a:t>NACH OBEN KOMMEN</a:t>
+              <a:t>UNTERRICHTSSTÖRUNGEN</a:t>
             </a:r>
             <a:endParaRPr lang="en-US" sz="1200" dirty="0"/>
           </a:p>
@@ -6669,7 +8029,7 @@
                 <a:ea typeface="Cambria" pitchFamily="34" charset="-122"/>
                 <a:cs typeface="Cambria" pitchFamily="34" charset="-120"/>
               </a:rPr>
-              <a:t>So verbesserst du deine mündliche Note</a:t>
+              <a:t>Was stört den Unterricht?</a:t>
             </a:r>
             <a:endParaRPr lang="en-US" sz="3200" dirty="0"/>
           </a:p>
@@ -6761,56 +8121,39 @@
         </p:nvSpPr>
         <p:spPr>
           <a:xfrm>
-            <a:off x="548640" y="1673352"/>
-            <a:ext cx="548640" cy="548640"/>
-          </a:xfrm>
-          <a:prstGeom prst="ellipse">
-            <a:avLst/>
+            <a:off x="548640" y="1600200"/>
+            <a:ext cx="5440680" cy="1234440"/>
+          </a:xfrm>
+          <a:prstGeom prst="roundRect">
+            <a:avLst>
+              <a:gd name="adj" fmla="val 5926"/>
+            </a:avLst>
           </a:prstGeom>
           <a:solidFill>
-            <a:srgbClr val="1E2761"/>
+            <a:srgbClr val="F4F7FD"/>
           </a:solidFill>
           <a:ln/>
         </p:spPr>
       </p:sp>
       <p:sp>
         <p:nvSpPr>
-          <p:cNvPr id="8" name="Text 5"/>
-          <p:cNvSpPr txBox="1"/>
-          <p:nvPr/>
-        </p:nvSpPr>
-        <p:spPr>
-          <a:xfrm>
-            <a:off x="548640" y="1673352"/>
-            <a:ext cx="548640" cy="548640"/>
-          </a:xfrm>
-          <a:prstGeom prst="rect">
-            <a:avLst/>
-          </a:prstGeom>
-          <a:noFill/>
-          <a:ln/>
-        </p:spPr>
-        <p:txBody>
-          <a:bodyPr wrap="square" lIns="0" tIns="0" rIns="0" bIns="0" rtlCol="0" anchor="ctr"/>
-          <a:lstStyle/>
-          <a:p>
-            <a:pPr algn="ctr" indent="0" marL="0">
-              <a:buNone/>
-            </a:pPr>
-            <a:r>
-              <a:rPr lang="en-US" sz="1800" b="1" dirty="0">
-                <a:solidFill>
-                  <a:srgbClr val="FFFFFF"/>
-                </a:solidFill>
-                <a:latin typeface="Calibri" pitchFamily="34" charset="0"/>
-                <a:ea typeface="Calibri" pitchFamily="34" charset="-122"/>
-                <a:cs typeface="Calibri" pitchFamily="34" charset="-120"/>
-              </a:rPr>
-              <a:t>1</a:t>
-            </a:r>
-            <a:endParaRPr lang="en-US" sz="1800" dirty="0"/>
-          </a:p>
-        </p:txBody>
+          <p:cNvPr id="8" name="Shape 5"/>
+          <p:cNvSpPr/>
+          <p:nvPr/>
+        </p:nvSpPr>
+        <p:spPr>
+          <a:xfrm>
+            <a:off x="548640" y="1600200"/>
+            <a:ext cx="109728" cy="1234440"/>
+          </a:xfrm>
+          <a:prstGeom prst="rect">
+            <a:avLst/>
+          </a:prstGeom>
+          <a:solidFill>
+            <a:srgbClr val="D9534F"/>
+          </a:solidFill>
+          <a:ln/>
+        </p:spPr>
       </p:sp>
       <p:sp>
         <p:nvSpPr>
@@ -6820,24 +8163,24 @@
         </p:nvSpPr>
         <p:spPr>
           <a:xfrm>
-            <a:off x="1325880" y="1600200"/>
-            <a:ext cx="10058400" cy="411480"/>
-          </a:xfrm>
-          <a:prstGeom prst="rect">
-            <a:avLst/>
-          </a:prstGeom>
-          <a:noFill/>
-          <a:ln/>
-        </p:spPr>
-        <p:txBody>
-          <a:bodyPr wrap="square" lIns="0" tIns="0" rIns="0" bIns="0" rtlCol="0" anchor="t"/>
-          <a:lstStyle/>
-          <a:p>
-            <a:pPr indent="0" marL="0">
-              <a:buNone/>
-            </a:pPr>
-            <a:r>
-              <a:rPr lang="en-US" sz="2100" b="1" dirty="0">
+            <a:off x="914400" y="1801368"/>
+            <a:ext cx="4937760" cy="411480"/>
+          </a:xfrm>
+          <a:prstGeom prst="rect">
+            <a:avLst/>
+          </a:prstGeom>
+          <a:noFill/>
+          <a:ln/>
+        </p:spPr>
+        <p:txBody>
+          <a:bodyPr wrap="square" lIns="0" tIns="0" rIns="0" bIns="0" rtlCol="0" anchor="t"/>
+          <a:lstStyle/>
+          <a:p>
+            <a:pPr indent="0" marL="0">
+              <a:buNone/>
+            </a:pPr>
+            <a:r>
+              <a:rPr lang="en-US" sz="2200" b="1" dirty="0">
                 <a:solidFill>
                   <a:srgbClr val="1E2761"/>
                 </a:solidFill>
@@ -6845,9 +8188,9 @@
                 <a:ea typeface="Cambria" pitchFamily="34" charset="-122"/>
                 <a:cs typeface="Cambria" pitchFamily="34" charset="-120"/>
               </a:rPr>
-              <a:t>Melde dich auch, wenn du unsicher bist.</a:t>
-            </a:r>
-            <a:endParaRPr lang="en-US" sz="2100" dirty="0"/>
+              <a:t>Reinrufen</a:t>
+            </a:r>
+            <a:endParaRPr lang="en-US" sz="2200" dirty="0"/>
           </a:p>
         </p:txBody>
       </p:sp>
@@ -6859,8 +8202,8 @@
         </p:nvSpPr>
         <p:spPr>
           <a:xfrm>
-            <a:off x="1325880" y="2011680"/>
-            <a:ext cx="10058400" cy="365760"/>
+            <a:off x="914400" y="2258568"/>
+            <a:ext cx="4937760" cy="411480"/>
           </a:xfrm>
           <a:prstGeom prst="rect">
             <a:avLst/>
@@ -6884,7 +8227,7 @@
                 <a:ea typeface="Calibri" pitchFamily="34" charset="-122"/>
                 <a:cs typeface="Calibri" pitchFamily="34" charset="-120"/>
               </a:rPr>
-              <a:t>Ein Fehler zählt nicht gegen dich – keine Mitarbeit schon.</a:t>
+              <a:t>ohne Melden dazwischenreden</a:t>
             </a:r>
             <a:endParaRPr lang="en-US" sz="1600" dirty="0"/>
           </a:p>
@@ -6898,56 +8241,39 @@
         </p:nvSpPr>
         <p:spPr>
           <a:xfrm>
-            <a:off x="548640" y="2587752"/>
-            <a:ext cx="548640" cy="548640"/>
-          </a:xfrm>
-          <a:prstGeom prst="ellipse">
-            <a:avLst/>
+            <a:off x="6172200" y="1600200"/>
+            <a:ext cx="5440680" cy="1234440"/>
+          </a:xfrm>
+          <a:prstGeom prst="roundRect">
+            <a:avLst>
+              <a:gd name="adj" fmla="val 5926"/>
+            </a:avLst>
           </a:prstGeom>
           <a:solidFill>
-            <a:srgbClr val="1E2761"/>
+            <a:srgbClr val="F4F7FD"/>
           </a:solidFill>
           <a:ln/>
         </p:spPr>
       </p:sp>
       <p:sp>
         <p:nvSpPr>
-          <p:cNvPr id="12" name="Text 9"/>
-          <p:cNvSpPr txBox="1"/>
-          <p:nvPr/>
-        </p:nvSpPr>
-        <p:spPr>
-          <a:xfrm>
-            <a:off x="548640" y="2587752"/>
-            <a:ext cx="548640" cy="548640"/>
-          </a:xfrm>
-          <a:prstGeom prst="rect">
-            <a:avLst/>
-          </a:prstGeom>
-          <a:noFill/>
-          <a:ln/>
-        </p:spPr>
-        <p:txBody>
-          <a:bodyPr wrap="square" lIns="0" tIns="0" rIns="0" bIns="0" rtlCol="0" anchor="ctr"/>
-          <a:lstStyle/>
-          <a:p>
-            <a:pPr algn="ctr" indent="0" marL="0">
-              <a:buNone/>
-            </a:pPr>
-            <a:r>
-              <a:rPr lang="en-US" sz="1800" b="1" dirty="0">
-                <a:solidFill>
-                  <a:srgbClr val="FFFFFF"/>
-                </a:solidFill>
-                <a:latin typeface="Calibri" pitchFamily="34" charset="0"/>
-                <a:ea typeface="Calibri" pitchFamily="34" charset="-122"/>
-                <a:cs typeface="Calibri" pitchFamily="34" charset="-120"/>
-              </a:rPr>
-              <a:t>2</a:t>
-            </a:r>
-            <a:endParaRPr lang="en-US" sz="1800" dirty="0"/>
-          </a:p>
-        </p:txBody>
+          <p:cNvPr id="12" name="Shape 9"/>
+          <p:cNvSpPr/>
+          <p:nvPr/>
+        </p:nvSpPr>
+        <p:spPr>
+          <a:xfrm>
+            <a:off x="6172200" y="1600200"/>
+            <a:ext cx="109728" cy="1234440"/>
+          </a:xfrm>
+          <a:prstGeom prst="rect">
+            <a:avLst/>
+          </a:prstGeom>
+          <a:solidFill>
+            <a:srgbClr val="D9534F"/>
+          </a:solidFill>
+          <a:ln/>
+        </p:spPr>
       </p:sp>
       <p:sp>
         <p:nvSpPr>
@@ -6957,24 +8283,24 @@
         </p:nvSpPr>
         <p:spPr>
           <a:xfrm>
-            <a:off x="1325880" y="2514600"/>
-            <a:ext cx="10058400" cy="411480"/>
-          </a:xfrm>
-          <a:prstGeom prst="rect">
-            <a:avLst/>
-          </a:prstGeom>
-          <a:noFill/>
-          <a:ln/>
-        </p:spPr>
-        <p:txBody>
-          <a:bodyPr wrap="square" lIns="0" tIns="0" rIns="0" bIns="0" rtlCol="0" anchor="t"/>
-          <a:lstStyle/>
-          <a:p>
-            <a:pPr indent="0" marL="0">
-              <a:buNone/>
-            </a:pPr>
-            <a:r>
-              <a:rPr lang="en-US" sz="2100" b="1" dirty="0">
+            <a:off x="6537960" y="1801368"/>
+            <a:ext cx="4937760" cy="411480"/>
+          </a:xfrm>
+          <a:prstGeom prst="rect">
+            <a:avLst/>
+          </a:prstGeom>
+          <a:noFill/>
+          <a:ln/>
+        </p:spPr>
+        <p:txBody>
+          <a:bodyPr wrap="square" lIns="0" tIns="0" rIns="0" bIns="0" rtlCol="0" anchor="t"/>
+          <a:lstStyle/>
+          <a:p>
+            <a:pPr indent="0" marL="0">
+              <a:buNone/>
+            </a:pPr>
+            <a:r>
+              <a:rPr lang="en-US" sz="2200" b="1" dirty="0">
                 <a:solidFill>
                   <a:srgbClr val="1E2761"/>
                 </a:solidFill>
@@ -6982,9 +8308,9 @@
                 <a:ea typeface="Cambria" pitchFamily="34" charset="-122"/>
                 <a:cs typeface="Cambria" pitchFamily="34" charset="-120"/>
               </a:rPr>
-              <a:t>Benutze Fachbegriffe.</a:t>
-            </a:r>
-            <a:endParaRPr lang="en-US" sz="2100" dirty="0"/>
+              <a:t>Nebengespräche</a:t>
+            </a:r>
+            <a:endParaRPr lang="en-US" sz="2200" dirty="0"/>
           </a:p>
         </p:txBody>
       </p:sp>
@@ -6996,8 +8322,8 @@
         </p:nvSpPr>
         <p:spPr>
           <a:xfrm>
-            <a:off x="1325880" y="2926080"/>
-            <a:ext cx="10058400" cy="365760"/>
+            <a:off x="6537960" y="2258568"/>
+            <a:ext cx="4937760" cy="411480"/>
           </a:xfrm>
           <a:prstGeom prst="rect">
             <a:avLst/>
@@ -7021,7 +8347,7 @@
                 <a:ea typeface="Calibri" pitchFamily="34" charset="-122"/>
                 <a:cs typeface="Calibri" pitchFamily="34" charset="-120"/>
               </a:rPr>
-              <a:t>Finite Form, Partizip II, Strophe, Vers … statt „das Wort da“.</a:t>
+              <a:t>während jemand anderes spricht oder alle arbeiten</a:t>
             </a:r>
             <a:endParaRPr lang="en-US" sz="1600" dirty="0"/>
           </a:p>
@@ -7035,56 +8361,39 @@
         </p:nvSpPr>
         <p:spPr>
           <a:xfrm>
-            <a:off x="548640" y="3502152"/>
-            <a:ext cx="548640" cy="548640"/>
-          </a:xfrm>
-          <a:prstGeom prst="ellipse">
-            <a:avLst/>
+            <a:off x="548640" y="3017520"/>
+            <a:ext cx="5440680" cy="1234440"/>
+          </a:xfrm>
+          <a:prstGeom prst="roundRect">
+            <a:avLst>
+              <a:gd name="adj" fmla="val 5926"/>
+            </a:avLst>
           </a:prstGeom>
           <a:solidFill>
-            <a:srgbClr val="1E2761"/>
+            <a:srgbClr val="F4F7FD"/>
           </a:solidFill>
           <a:ln/>
         </p:spPr>
       </p:sp>
       <p:sp>
         <p:nvSpPr>
-          <p:cNvPr id="16" name="Text 13"/>
-          <p:cNvSpPr txBox="1"/>
-          <p:nvPr/>
-        </p:nvSpPr>
-        <p:spPr>
-          <a:xfrm>
-            <a:off x="548640" y="3502152"/>
-            <a:ext cx="548640" cy="548640"/>
-          </a:xfrm>
-          <a:prstGeom prst="rect">
-            <a:avLst/>
-          </a:prstGeom>
-          <a:noFill/>
-          <a:ln/>
-        </p:spPr>
-        <p:txBody>
-          <a:bodyPr wrap="square" lIns="0" tIns="0" rIns="0" bIns="0" rtlCol="0" anchor="ctr"/>
-          <a:lstStyle/>
-          <a:p>
-            <a:pPr algn="ctr" indent="0" marL="0">
-              <a:buNone/>
-            </a:pPr>
-            <a:r>
-              <a:rPr lang="en-US" sz="1800" b="1" dirty="0">
-                <a:solidFill>
-                  <a:srgbClr val="FFFFFF"/>
-                </a:solidFill>
-                <a:latin typeface="Calibri" pitchFamily="34" charset="0"/>
-                <a:ea typeface="Calibri" pitchFamily="34" charset="-122"/>
-                <a:cs typeface="Calibri" pitchFamily="34" charset="-120"/>
-              </a:rPr>
-              <a:t>3</a:t>
-            </a:r>
-            <a:endParaRPr lang="en-US" sz="1800" dirty="0"/>
-          </a:p>
-        </p:txBody>
+          <p:cNvPr id="16" name="Shape 13"/>
+          <p:cNvSpPr/>
+          <p:nvPr/>
+        </p:nvSpPr>
+        <p:spPr>
+          <a:xfrm>
+            <a:off x="548640" y="3017520"/>
+            <a:ext cx="109728" cy="1234440"/>
+          </a:xfrm>
+          <a:prstGeom prst="rect">
+            <a:avLst/>
+          </a:prstGeom>
+          <a:solidFill>
+            <a:srgbClr val="D9534F"/>
+          </a:solidFill>
+          <a:ln/>
+        </p:spPr>
       </p:sp>
       <p:sp>
         <p:nvSpPr>
@@ -7094,24 +8403,24 @@
         </p:nvSpPr>
         <p:spPr>
           <a:xfrm>
-            <a:off x="1325880" y="3429000"/>
-            <a:ext cx="10058400" cy="411480"/>
-          </a:xfrm>
-          <a:prstGeom prst="rect">
-            <a:avLst/>
-          </a:prstGeom>
-          <a:noFill/>
-          <a:ln/>
-        </p:spPr>
-        <p:txBody>
-          <a:bodyPr wrap="square" lIns="0" tIns="0" rIns="0" bIns="0" rtlCol="0" anchor="t"/>
-          <a:lstStyle/>
-          <a:p>
-            <a:pPr indent="0" marL="0">
-              <a:buNone/>
-            </a:pPr>
-            <a:r>
-              <a:rPr lang="en-US" sz="2100" b="1" dirty="0">
+            <a:off x="914400" y="3218688"/>
+            <a:ext cx="4937760" cy="411480"/>
+          </a:xfrm>
+          <a:prstGeom prst="rect">
+            <a:avLst/>
+          </a:prstGeom>
+          <a:noFill/>
+          <a:ln/>
+        </p:spPr>
+        <p:txBody>
+          <a:bodyPr wrap="square" lIns="0" tIns="0" rIns="0" bIns="0" rtlCol="0" anchor="t"/>
+          <a:lstStyle/>
+          <a:p>
+            <a:pPr indent="0" marL="0">
+              <a:buNone/>
+            </a:pPr>
+            <a:r>
+              <a:rPr lang="en-US" sz="2200" b="1" dirty="0">
                 <a:solidFill>
                   <a:srgbClr val="1E2761"/>
                 </a:solidFill>
@@ -7119,9 +8428,9 @@
                 <a:ea typeface="Cambria" pitchFamily="34" charset="-122"/>
                 <a:cs typeface="Cambria" pitchFamily="34" charset="-120"/>
               </a:rPr>
-              <a:t>Begründe mit „weil“.</a:t>
-            </a:r>
-            <a:endParaRPr lang="en-US" sz="2100" dirty="0"/>
+              <a:t>Handy</a:t>
+            </a:r>
+            <a:endParaRPr lang="en-US" sz="2200" dirty="0"/>
           </a:p>
         </p:txBody>
       </p:sp>
@@ -7133,8 +8442,8 @@
         </p:nvSpPr>
         <p:spPr>
           <a:xfrm>
-            <a:off x="1325880" y="3840480"/>
-            <a:ext cx="10058400" cy="365760"/>
+            <a:off x="914400" y="3675888"/>
+            <a:ext cx="4937760" cy="411480"/>
           </a:xfrm>
           <a:prstGeom prst="rect">
             <a:avLst/>
@@ -7158,7 +8467,7 @@
                 <a:ea typeface="Calibri" pitchFamily="34" charset="-122"/>
                 <a:cs typeface="Calibri" pitchFamily="34" charset="-120"/>
               </a:rPr>
-              <a:t>Eine Antwort mit Begründung ist mehr wert als ein einzelnes Wort.</a:t>
+              <a:t>benutzen oder sichtbar auf dem Tisch</a:t>
             </a:r>
             <a:endParaRPr lang="en-US" sz="1600" dirty="0"/>
           </a:p>
@@ -7172,56 +8481,39 @@
         </p:nvSpPr>
         <p:spPr>
           <a:xfrm>
-            <a:off x="548640" y="4416552"/>
-            <a:ext cx="548640" cy="548640"/>
-          </a:xfrm>
-          <a:prstGeom prst="ellipse">
-            <a:avLst/>
+            <a:off x="6172200" y="3017520"/>
+            <a:ext cx="5440680" cy="1234440"/>
+          </a:xfrm>
+          <a:prstGeom prst="roundRect">
+            <a:avLst>
+              <a:gd name="adj" fmla="val 5926"/>
+            </a:avLst>
           </a:prstGeom>
           <a:solidFill>
-            <a:srgbClr val="1E2761"/>
+            <a:srgbClr val="F4F7FD"/>
           </a:solidFill>
           <a:ln/>
         </p:spPr>
       </p:sp>
       <p:sp>
         <p:nvSpPr>
-          <p:cNvPr id="20" name="Text 17"/>
-          <p:cNvSpPr txBox="1"/>
-          <p:nvPr/>
-        </p:nvSpPr>
-        <p:spPr>
-          <a:xfrm>
-            <a:off x="548640" y="4416552"/>
-            <a:ext cx="548640" cy="548640"/>
-          </a:xfrm>
-          <a:prstGeom prst="rect">
-            <a:avLst/>
-          </a:prstGeom>
-          <a:noFill/>
-          <a:ln/>
-        </p:spPr>
-        <p:txBody>
-          <a:bodyPr wrap="square" lIns="0" tIns="0" rIns="0" bIns="0" rtlCol="0" anchor="ctr"/>
-          <a:lstStyle/>
-          <a:p>
-            <a:pPr algn="ctr" indent="0" marL="0">
-              <a:buNone/>
-            </a:pPr>
-            <a:r>
-              <a:rPr lang="en-US" sz="1800" b="1" dirty="0">
-                <a:solidFill>
-                  <a:srgbClr val="FFFFFF"/>
-                </a:solidFill>
-                <a:latin typeface="Calibri" pitchFamily="34" charset="0"/>
-                <a:ea typeface="Calibri" pitchFamily="34" charset="-122"/>
-                <a:cs typeface="Calibri" pitchFamily="34" charset="-120"/>
-              </a:rPr>
-              <a:t>4</a:t>
-            </a:r>
-            <a:endParaRPr lang="en-US" sz="1800" dirty="0"/>
-          </a:p>
-        </p:txBody>
+          <p:cNvPr id="20" name="Shape 17"/>
+          <p:cNvSpPr/>
+          <p:nvPr/>
+        </p:nvSpPr>
+        <p:spPr>
+          <a:xfrm>
+            <a:off x="6172200" y="3017520"/>
+            <a:ext cx="109728" cy="1234440"/>
+          </a:xfrm>
+          <a:prstGeom prst="rect">
+            <a:avLst/>
+          </a:prstGeom>
+          <a:solidFill>
+            <a:srgbClr val="D9534F"/>
+          </a:solidFill>
+          <a:ln/>
+        </p:spPr>
       </p:sp>
       <p:sp>
         <p:nvSpPr>
@@ -7231,24 +8523,24 @@
         </p:nvSpPr>
         <p:spPr>
           <a:xfrm>
-            <a:off x="1325880" y="4343400"/>
-            <a:ext cx="10058400" cy="411480"/>
-          </a:xfrm>
-          <a:prstGeom prst="rect">
-            <a:avLst/>
-          </a:prstGeom>
-          <a:noFill/>
-          <a:ln/>
-        </p:spPr>
-        <p:txBody>
-          <a:bodyPr wrap="square" lIns="0" tIns="0" rIns="0" bIns="0" rtlCol="0" anchor="t"/>
-          <a:lstStyle/>
-          <a:p>
-            <a:pPr indent="0" marL="0">
-              <a:buNone/>
-            </a:pPr>
-            <a:r>
-              <a:rPr lang="en-US" sz="2100" b="1" dirty="0">
+            <a:off x="6537960" y="3218688"/>
+            <a:ext cx="4937760" cy="411480"/>
+          </a:xfrm>
+          <a:prstGeom prst="rect">
+            <a:avLst/>
+          </a:prstGeom>
+          <a:noFill/>
+          <a:ln/>
+        </p:spPr>
+        <p:txBody>
+          <a:bodyPr wrap="square" lIns="0" tIns="0" rIns="0" bIns="0" rtlCol="0" anchor="t"/>
+          <a:lstStyle/>
+          <a:p>
+            <a:pPr indent="0" marL="0">
+              <a:buNone/>
+            </a:pPr>
+            <a:r>
+              <a:rPr lang="en-US" sz="2200" b="1" dirty="0">
                 <a:solidFill>
                   <a:srgbClr val="1E2761"/>
                 </a:solidFill>
@@ -7256,9 +8548,9 @@
                 <a:ea typeface="Cambria" pitchFamily="34" charset="-122"/>
                 <a:cs typeface="Cambria" pitchFamily="34" charset="-120"/>
               </a:rPr>
-              <a:t>Verknüpfe mit früheren Stunden.</a:t>
-            </a:r>
-            <a:endParaRPr lang="en-US" sz="2100" dirty="0"/>
+              <a:t>Nicht arbeiten</a:t>
+            </a:r>
+            <a:endParaRPr lang="en-US" sz="2200" dirty="0"/>
           </a:p>
         </p:txBody>
       </p:sp>
@@ -7270,8 +8562,8 @@
         </p:nvSpPr>
         <p:spPr>
           <a:xfrm>
-            <a:off x="1325880" y="4754880"/>
-            <a:ext cx="10058400" cy="365760"/>
+            <a:off x="6537960" y="3675888"/>
+            <a:ext cx="4937760" cy="411480"/>
           </a:xfrm>
           <a:prstGeom prst="rect">
             <a:avLst/>
@@ -7295,7 +8587,7 @@
                 <a:ea typeface="Calibri" pitchFamily="34" charset="-122"/>
                 <a:cs typeface="Calibri" pitchFamily="34" charset="-120"/>
               </a:rPr>
-              <a:t>„Das ist wie beim …“ – genau das macht den Unterschied zwischen 4 und 3.</a:t>
+              <a:t>Aufgabe liegen lassen, andere ablenken</a:t>
             </a:r>
             <a:endParaRPr lang="en-US" sz="1600" dirty="0"/>
           </a:p>
@@ -7309,56 +8601,39 @@
         </p:nvSpPr>
         <p:spPr>
           <a:xfrm>
-            <a:off x="548640" y="5330952"/>
-            <a:ext cx="548640" cy="548640"/>
-          </a:xfrm>
-          <a:prstGeom prst="ellipse">
-            <a:avLst/>
+            <a:off x="548640" y="4434840"/>
+            <a:ext cx="5440680" cy="1234440"/>
+          </a:xfrm>
+          <a:prstGeom prst="roundRect">
+            <a:avLst>
+              <a:gd name="adj" fmla="val 5926"/>
+            </a:avLst>
           </a:prstGeom>
           <a:solidFill>
-            <a:srgbClr val="1E2761"/>
+            <a:srgbClr val="F4F7FD"/>
           </a:solidFill>
           <a:ln/>
         </p:spPr>
       </p:sp>
       <p:sp>
         <p:nvSpPr>
-          <p:cNvPr id="24" name="Text 21"/>
-          <p:cNvSpPr txBox="1"/>
-          <p:nvPr/>
-        </p:nvSpPr>
-        <p:spPr>
-          <a:xfrm>
-            <a:off x="548640" y="5330952"/>
-            <a:ext cx="548640" cy="548640"/>
-          </a:xfrm>
-          <a:prstGeom prst="rect">
-            <a:avLst/>
-          </a:prstGeom>
-          <a:noFill/>
-          <a:ln/>
-        </p:spPr>
-        <p:txBody>
-          <a:bodyPr wrap="square" lIns="0" tIns="0" rIns="0" bIns="0" rtlCol="0" anchor="ctr"/>
-          <a:lstStyle/>
-          <a:p>
-            <a:pPr algn="ctr" indent="0" marL="0">
-              <a:buNone/>
-            </a:pPr>
-            <a:r>
-              <a:rPr lang="en-US" sz="1800" b="1" dirty="0">
-                <a:solidFill>
-                  <a:srgbClr val="FFFFFF"/>
-                </a:solidFill>
-                <a:latin typeface="Calibri" pitchFamily="34" charset="0"/>
-                <a:ea typeface="Calibri" pitchFamily="34" charset="-122"/>
-                <a:cs typeface="Calibri" pitchFamily="34" charset="-120"/>
-              </a:rPr>
-              <a:t>5</a:t>
-            </a:r>
-            <a:endParaRPr lang="en-US" sz="1800" dirty="0"/>
-          </a:p>
-        </p:txBody>
+          <p:cNvPr id="24" name="Shape 21"/>
+          <p:cNvSpPr/>
+          <p:nvPr/>
+        </p:nvSpPr>
+        <p:spPr>
+          <a:xfrm>
+            <a:off x="548640" y="4434840"/>
+            <a:ext cx="109728" cy="1234440"/>
+          </a:xfrm>
+          <a:prstGeom prst="rect">
+            <a:avLst/>
+          </a:prstGeom>
+          <a:solidFill>
+            <a:srgbClr val="D9534F"/>
+          </a:solidFill>
+          <a:ln/>
+        </p:spPr>
       </p:sp>
       <p:sp>
         <p:nvSpPr>
@@ -7368,24 +8643,24 @@
         </p:nvSpPr>
         <p:spPr>
           <a:xfrm>
-            <a:off x="1325880" y="5257800"/>
-            <a:ext cx="10058400" cy="411480"/>
-          </a:xfrm>
-          <a:prstGeom prst="rect">
-            <a:avLst/>
-          </a:prstGeom>
-          <a:noFill/>
-          <a:ln/>
-        </p:spPr>
-        <p:txBody>
-          <a:bodyPr wrap="square" lIns="0" tIns="0" rIns="0" bIns="0" rtlCol="0" anchor="t"/>
-          <a:lstStyle/>
-          <a:p>
-            <a:pPr indent="0" marL="0">
-              <a:buNone/>
-            </a:pPr>
-            <a:r>
-              <a:rPr lang="en-US" sz="2100" b="1" dirty="0">
+            <a:off x="914400" y="4636008"/>
+            <a:ext cx="4937760" cy="411480"/>
+          </a:xfrm>
+          <a:prstGeom prst="rect">
+            <a:avLst/>
+          </a:prstGeom>
+          <a:noFill/>
+          <a:ln/>
+        </p:spPr>
+        <p:txBody>
+          <a:bodyPr wrap="square" lIns="0" tIns="0" rIns="0" bIns="0" rtlCol="0" anchor="t"/>
+          <a:lstStyle/>
+          <a:p>
+            <a:pPr indent="0" marL="0">
+              <a:buNone/>
+            </a:pPr>
+            <a:r>
+              <a:rPr lang="en-US" sz="2200" b="1" dirty="0">
                 <a:solidFill>
                   <a:srgbClr val="1E2761"/>
                 </a:solidFill>
@@ -7393,9 +8668,9 @@
                 <a:ea typeface="Cambria" pitchFamily="34" charset="-122"/>
                 <a:cs typeface="Cambria" pitchFamily="34" charset="-120"/>
               </a:rPr>
-              <a:t>Hör zu und knüpf an.</a:t>
-            </a:r>
-            <a:endParaRPr lang="en-US" sz="2100" dirty="0"/>
+              <a:t>Herumlaufen</a:t>
+            </a:r>
+            <a:endParaRPr lang="en-US" sz="2200" dirty="0"/>
           </a:p>
         </p:txBody>
       </p:sp>
@@ -7407,8 +8682,8 @@
         </p:nvSpPr>
         <p:spPr>
           <a:xfrm>
-            <a:off x="1325880" y="5669280"/>
-            <a:ext cx="10058400" cy="365760"/>
+            <a:off x="914400" y="5093208"/>
+            <a:ext cx="4937760" cy="411480"/>
           </a:xfrm>
           <a:prstGeom prst="rect">
             <a:avLst/>
@@ -7432,7 +8707,166 @@
                 <a:ea typeface="Calibri" pitchFamily="34" charset="-122"/>
                 <a:cs typeface="Calibri" pitchFamily="34" charset="-120"/>
               </a:rPr>
-              <a:t>„Ich ergänze zu …“ oder „Ich sehe das anders, weil …“</a:t>
+              <a:t>ohne Auftrag den Platz verlassen</a:t>
+            </a:r>
+            <a:endParaRPr lang="en-US" sz="1600" dirty="0"/>
+          </a:p>
+        </p:txBody>
+      </p:sp>
+      <p:sp>
+        <p:nvSpPr>
+          <p:cNvPr id="27" name="Shape 24"/>
+          <p:cNvSpPr/>
+          <p:nvPr/>
+        </p:nvSpPr>
+        <p:spPr>
+          <a:xfrm>
+            <a:off x="6172200" y="4434840"/>
+            <a:ext cx="5440680" cy="1234440"/>
+          </a:xfrm>
+          <a:prstGeom prst="roundRect">
+            <a:avLst>
+              <a:gd name="adj" fmla="val 5926"/>
+            </a:avLst>
+          </a:prstGeom>
+          <a:solidFill>
+            <a:srgbClr val="F4F7FD"/>
+          </a:solidFill>
+          <a:ln/>
+        </p:spPr>
+      </p:sp>
+      <p:sp>
+        <p:nvSpPr>
+          <p:cNvPr id="28" name="Shape 25"/>
+          <p:cNvSpPr/>
+          <p:nvPr/>
+        </p:nvSpPr>
+        <p:spPr>
+          <a:xfrm>
+            <a:off x="6172200" y="4434840"/>
+            <a:ext cx="109728" cy="1234440"/>
+          </a:xfrm>
+          <a:prstGeom prst="rect">
+            <a:avLst/>
+          </a:prstGeom>
+          <a:solidFill>
+            <a:srgbClr val="D9534F"/>
+          </a:solidFill>
+          <a:ln/>
+        </p:spPr>
+      </p:sp>
+      <p:sp>
+        <p:nvSpPr>
+          <p:cNvPr id="29" name="Text 26"/>
+          <p:cNvSpPr txBox="1"/>
+          <p:nvPr/>
+        </p:nvSpPr>
+        <p:spPr>
+          <a:xfrm>
+            <a:off x="6537960" y="4636008"/>
+            <a:ext cx="4937760" cy="411480"/>
+          </a:xfrm>
+          <a:prstGeom prst="rect">
+            <a:avLst/>
+          </a:prstGeom>
+          <a:noFill/>
+          <a:ln/>
+        </p:spPr>
+        <p:txBody>
+          <a:bodyPr wrap="square" lIns="0" tIns="0" rIns="0" bIns="0" rtlCol="0" anchor="t"/>
+          <a:lstStyle/>
+          <a:p>
+            <a:pPr indent="0" marL="0">
+              <a:buNone/>
+            </a:pPr>
+            <a:r>
+              <a:rPr lang="en-US" sz="2200" b="1" dirty="0">
+                <a:solidFill>
+                  <a:srgbClr val="1E2761"/>
+                </a:solidFill>
+                <a:latin typeface="Cambria" pitchFamily="34" charset="0"/>
+                <a:ea typeface="Cambria" pitchFamily="34" charset="-122"/>
+                <a:cs typeface="Cambria" pitchFamily="34" charset="-120"/>
+              </a:rPr>
+              <a:t>Material fehlt</a:t>
+            </a:r>
+            <a:endParaRPr lang="en-US" sz="2200" dirty="0"/>
+          </a:p>
+        </p:txBody>
+      </p:sp>
+      <p:sp>
+        <p:nvSpPr>
+          <p:cNvPr id="30" name="Text 27"/>
+          <p:cNvSpPr txBox="1"/>
+          <p:nvPr/>
+        </p:nvSpPr>
+        <p:spPr>
+          <a:xfrm>
+            <a:off x="6537960" y="5093208"/>
+            <a:ext cx="4937760" cy="411480"/>
+          </a:xfrm>
+          <a:prstGeom prst="rect">
+            <a:avLst/>
+          </a:prstGeom>
+          <a:noFill/>
+          <a:ln/>
+        </p:spPr>
+        <p:txBody>
+          <a:bodyPr wrap="square" lIns="0" tIns="0" rIns="0" bIns="0" rtlCol="0" anchor="t"/>
+          <a:lstStyle/>
+          <a:p>
+            <a:pPr indent="0" marL="0">
+              <a:buNone/>
+            </a:pPr>
+            <a:r>
+              <a:rPr lang="en-US" sz="1600" dirty="0">
+                <a:solidFill>
+                  <a:srgbClr val="5B6B8C"/>
+                </a:solidFill>
+                <a:latin typeface="Calibri" pitchFamily="34" charset="0"/>
+                <a:ea typeface="Calibri" pitchFamily="34" charset="-122"/>
+                <a:cs typeface="Calibri" pitchFamily="34" charset="-120"/>
+              </a:rPr>
+              <a:t>Heft, Buch oder Stifte nicht dabei</a:t>
+            </a:r>
+            <a:endParaRPr lang="en-US" sz="1600" dirty="0"/>
+          </a:p>
+        </p:txBody>
+      </p:sp>
+      <p:sp>
+        <p:nvSpPr>
+          <p:cNvPr id="31" name="Text 28"/>
+          <p:cNvSpPr txBox="1"/>
+          <p:nvPr/>
+        </p:nvSpPr>
+        <p:spPr>
+          <a:xfrm>
+            <a:off x="548640" y="5943600"/>
+            <a:ext cx="11064240" cy="365760"/>
+          </a:xfrm>
+          <a:prstGeom prst="rect">
+            <a:avLst/>
+          </a:prstGeom>
+          <a:noFill/>
+          <a:ln/>
+        </p:spPr>
+        <p:txBody>
+          <a:bodyPr wrap="square" lIns="0" tIns="0" rIns="0" bIns="0" rtlCol="0" anchor="t"/>
+          <a:lstStyle/>
+          <a:p>
+            <a:pPr algn="ctr" indent="0" marL="0">
+              <a:buNone/>
+            </a:pPr>
+            <a:r>
+              <a:rPr lang="en-US" sz="1600" i="1" dirty="0">
+                <a:solidFill>
+                  <a:srgbClr val="1E2761"/>
+                </a:solidFill>
+                <a:latin typeface="Calibri" pitchFamily="34" charset="0"/>
+                <a:ea typeface="Calibri" pitchFamily="34" charset="-122"/>
+                <a:cs typeface="Calibri" pitchFamily="34" charset="-120"/>
+              </a:rPr>
+              <a:t>Wer stört, hält nicht nur sich selbst vom Lernen ab, sondern auch alle anderen.</a:t>
             </a:r>
             <a:endParaRPr lang="en-US" sz="1600" dirty="0"/>
           </a:p>
@@ -7452,7 +8886,7 @@
     <p:bg>
       <p:bgPr>
         <a:solidFill>
-          <a:srgbClr val="1E2761"/>
+          <a:srgbClr val="FFFFFF"/>
         </a:solidFill>
       </p:bgPr>
     </p:bg>
@@ -7472,80 +8906,118 @@
       </p:grpSpPr>
       <p:sp>
         <p:nvSpPr>
-          <p:cNvPr id="2" name="Shape 0"/>
-          <p:cNvSpPr/>
-          <p:nvPr/>
-        </p:nvSpPr>
-        <p:spPr>
-          <a:xfrm>
-            <a:off x="9692640" y="-1463040"/>
-            <a:ext cx="4206240" cy="4206240"/>
-          </a:xfrm>
-          <a:prstGeom prst="ellipse">
-            <a:avLst/>
-          </a:prstGeom>
-          <a:solidFill>
-            <a:srgbClr val="24306E"/>
-          </a:solidFill>
-          <a:ln/>
-        </p:spPr>
-      </p:sp>
-      <p:sp>
-        <p:nvSpPr>
-          <p:cNvPr id="3" name="Shape 1"/>
-          <p:cNvSpPr/>
-          <p:nvPr/>
-        </p:nvSpPr>
-        <p:spPr>
-          <a:xfrm>
-            <a:off x="-1371600" y="4206240"/>
-            <a:ext cx="3657600" cy="3657600"/>
-          </a:xfrm>
-          <a:prstGeom prst="ellipse">
-            <a:avLst/>
-          </a:prstGeom>
-          <a:solidFill>
-            <a:srgbClr val="24306E"/>
-          </a:solidFill>
-          <a:ln/>
-        </p:spPr>
-      </p:sp>
-      <p:sp>
-        <p:nvSpPr>
-          <p:cNvPr id="4" name="Text 2"/>
-          <p:cNvSpPr txBox="1"/>
-          <p:nvPr/>
-        </p:nvSpPr>
-        <p:spPr>
-          <a:xfrm>
-            <a:off x="822960" y="1737360"/>
-            <a:ext cx="10058400" cy="822960"/>
-          </a:xfrm>
-          <a:prstGeom prst="rect">
-            <a:avLst/>
-          </a:prstGeom>
-          <a:noFill/>
-          <a:ln/>
-        </p:spPr>
-        <p:txBody>
-          <a:bodyPr wrap="square" lIns="0" tIns="0" rIns="0" bIns="0" rtlCol="0" anchor="t"/>
-          <a:lstStyle/>
-          <a:p>
-            <a:pPr indent="0" marL="0">
-              <a:buNone/>
-            </a:pPr>
-            <a:r>
-              <a:rPr lang="en-US" sz="4000" b="1" dirty="0">
-                <a:solidFill>
-                  <a:srgbClr val="FFFFFF"/>
+          <p:cNvPr id="2" name="Text 0"/>
+          <p:cNvSpPr txBox="1"/>
+          <p:nvPr/>
+        </p:nvSpPr>
+        <p:spPr>
+          <a:xfrm>
+            <a:off x="548640" y="365760"/>
+            <a:ext cx="7315200" cy="274320"/>
+          </a:xfrm>
+          <a:prstGeom prst="rect">
+            <a:avLst/>
+          </a:prstGeom>
+          <a:noFill/>
+          <a:ln/>
+        </p:spPr>
+        <p:txBody>
+          <a:bodyPr wrap="square" lIns="0" tIns="0" rIns="0" bIns="0" rtlCol="0" anchor="t"/>
+          <a:lstStyle/>
+          <a:p>
+            <a:pPr indent="0" marL="0">
+              <a:buNone/>
+            </a:pPr>
+            <a:r>
+              <a:rPr lang="en-US" sz="1200" spc="200" kern="0" dirty="0">
+                <a:solidFill>
+                  <a:srgbClr val="5B6B8C"/>
+                </a:solidFill>
+                <a:latin typeface="Calibri" pitchFamily="34" charset="0"/>
+                <a:ea typeface="Calibri" pitchFamily="34" charset="-122"/>
+                <a:cs typeface="Calibri" pitchFamily="34" charset="-120"/>
+              </a:rPr>
+              <a:t>UNTERRICHTSSTÖRUNGEN</a:t>
+            </a:r>
+            <a:endParaRPr lang="en-US" sz="1200" dirty="0"/>
+          </a:p>
+        </p:txBody>
+      </p:sp>
+      <p:sp>
+        <p:nvSpPr>
+          <p:cNvPr id="3" name="Text 1"/>
+          <p:cNvSpPr txBox="1"/>
+          <p:nvPr/>
+        </p:nvSpPr>
+        <p:spPr>
+          <a:xfrm>
+            <a:off x="548640" y="658368"/>
+            <a:ext cx="11064240" cy="640080"/>
+          </a:xfrm>
+          <a:prstGeom prst="rect">
+            <a:avLst/>
+          </a:prstGeom>
+          <a:noFill/>
+          <a:ln/>
+        </p:spPr>
+        <p:txBody>
+          <a:bodyPr wrap="square" lIns="0" tIns="0" rIns="0" bIns="0" rtlCol="0" anchor="t"/>
+          <a:lstStyle/>
+          <a:p>
+            <a:pPr indent="0" marL="0">
+              <a:buNone/>
+            </a:pPr>
+            <a:r>
+              <a:rPr lang="en-US" sz="3200" b="1" dirty="0">
+                <a:solidFill>
+                  <a:srgbClr val="1E2761"/>
                 </a:solidFill>
                 <a:latin typeface="Cambria" pitchFamily="34" charset="0"/>
                 <a:ea typeface="Cambria" pitchFamily="34" charset="-122"/>
                 <a:cs typeface="Cambria" pitchFamily="34" charset="-120"/>
               </a:rPr>
-              <a:t>Und jetzt?</a:t>
-            </a:r>
-            <a:endParaRPr lang="en-US" sz="4000" dirty="0"/>
+              <a:t>So reagiere ich – Stufe für Stufe</a:t>
+            </a:r>
+            <a:endParaRPr lang="en-US" sz="3200" dirty="0"/>
+          </a:p>
+        </p:txBody>
+      </p:sp>
+      <p:sp>
+        <p:nvSpPr>
+          <p:cNvPr id="4" name="Text 2"/>
+          <p:cNvSpPr txBox="1"/>
+          <p:nvPr/>
+        </p:nvSpPr>
+        <p:spPr>
+          <a:xfrm>
+            <a:off x="548640" y="6400800"/>
+            <a:ext cx="5486400" cy="228600"/>
+          </a:xfrm>
+          <a:prstGeom prst="rect">
+            <a:avLst/>
+          </a:prstGeom>
+          <a:noFill/>
+          <a:ln/>
+        </p:spPr>
+        <p:txBody>
+          <a:bodyPr wrap="square" lIns="0" tIns="0" rIns="0" bIns="0" rtlCol="0" anchor="t"/>
+          <a:lstStyle/>
+          <a:p>
+            <a:pPr indent="0" marL="0">
+              <a:buNone/>
+            </a:pPr>
+            <a:r>
+              <a:rPr lang="en-US" sz="1000" dirty="0">
+                <a:solidFill>
+                  <a:srgbClr val="5B6B8C"/>
+                </a:solidFill>
+                <a:latin typeface="Calibri" pitchFamily="34" charset="0"/>
+                <a:ea typeface="Calibri" pitchFamily="34" charset="-122"/>
+                <a:cs typeface="Calibri" pitchFamily="34" charset="-120"/>
+              </a:rPr>
+              <a:t>Mündliche Noten · Deutsch 7A</a:t>
+            </a:r>
+            <a:endParaRPr lang="en-US" sz="1000" dirty="0"/>
           </a:p>
         </p:txBody>
       </p:sp>
@@ -7557,38 +9029,85 @@
         </p:nvSpPr>
         <p:spPr>
           <a:xfrm>
-            <a:off x="822960" y="2834640"/>
-            <a:ext cx="10515600" cy="640080"/>
-          </a:xfrm>
-          <a:prstGeom prst="rect">
-            <a:avLst/>
-          </a:prstGeom>
-          <a:noFill/>
-          <a:ln/>
-        </p:spPr>
-        <p:txBody>
-          <a:bodyPr wrap="square" lIns="0" tIns="0" rIns="0" bIns="0" rtlCol="0" anchor="t"/>
-          <a:lstStyle/>
-          <a:p>
-            <a:pPr indent="0" marL="0">
-              <a:buNone/>
-            </a:pPr>
-            <a:r>
-              <a:rPr lang="en-US" sz="2200" b="1" dirty="0">
-                <a:solidFill>
-                  <a:srgbClr val="E8A33D"/>
-                </a:solidFill>
-                <a:latin typeface="Calibri" pitchFamily="34" charset="0"/>
-                <a:ea typeface="Calibri" pitchFamily="34" charset="-122"/>
-                <a:cs typeface="Calibri" pitchFamily="34" charset="-120"/>
-              </a:rPr>
-              <a:t>1  </a:t>
-            </a:r>
-            <a:pPr indent="0" marL="0">
-              <a:buNone/>
-            </a:pPr>
-            <a:r>
-              <a:rPr lang="en-US" sz="2200" dirty="0">
+            <a:off x="11155680" y="6400800"/>
+            <a:ext cx="457200" cy="228600"/>
+          </a:xfrm>
+          <a:prstGeom prst="rect">
+            <a:avLst/>
+          </a:prstGeom>
+          <a:noFill/>
+          <a:ln/>
+        </p:spPr>
+        <p:txBody>
+          <a:bodyPr wrap="square" lIns="0" tIns="0" rIns="0" bIns="0" rtlCol="0" anchor="t"/>
+          <a:lstStyle/>
+          <a:p>
+            <a:pPr algn="r" indent="0" marL="0">
+              <a:buNone/>
+            </a:pPr>
+            <a:r>
+              <a:rPr lang="en-US" sz="1000" dirty="0">
+                <a:solidFill>
+                  <a:srgbClr val="5B6B8C"/>
+                </a:solidFill>
+                <a:latin typeface="Calibri" pitchFamily="34" charset="0"/>
+                <a:ea typeface="Calibri" pitchFamily="34" charset="-122"/>
+                <a:cs typeface="Calibri" pitchFamily="34" charset="-120"/>
+              </a:rPr>
+              <a:t>9</a:t>
+            </a:r>
+            <a:endParaRPr lang="en-US" sz="1000" dirty="0"/>
+          </a:p>
+        </p:txBody>
+      </p:sp>
+      <p:sp>
+        <p:nvSpPr>
+          <p:cNvPr id="7" name="Shape 4"/>
+          <p:cNvSpPr/>
+          <p:nvPr/>
+        </p:nvSpPr>
+        <p:spPr>
+          <a:xfrm>
+            <a:off x="548640" y="3931920"/>
+            <a:ext cx="2103120" cy="2103120"/>
+          </a:xfrm>
+          <a:prstGeom prst="roundRect">
+            <a:avLst>
+              <a:gd name="adj" fmla="val 2174"/>
+            </a:avLst>
+          </a:prstGeom>
+          <a:solidFill>
+            <a:srgbClr val="9DB84A"/>
+          </a:solidFill>
+          <a:ln/>
+        </p:spPr>
+      </p:sp>
+      <p:sp>
+        <p:nvSpPr>
+          <p:cNvPr id="8" name="Text 5"/>
+          <p:cNvSpPr txBox="1"/>
+          <p:nvPr/>
+        </p:nvSpPr>
+        <p:spPr>
+          <a:xfrm>
+            <a:off x="548640" y="4069080"/>
+            <a:ext cx="2103120" cy="365760"/>
+          </a:xfrm>
+          <a:prstGeom prst="rect">
+            <a:avLst/>
+          </a:prstGeom>
+          <a:noFill/>
+          <a:ln/>
+        </p:spPr>
+        <p:txBody>
+          <a:bodyPr wrap="square" lIns="0" tIns="0" rIns="0" bIns="0" rtlCol="0" anchor="t"/>
+          <a:lstStyle/>
+          <a:p>
+            <a:pPr algn="ctr" indent="0" marL="0">
+              <a:buNone/>
+            </a:pPr>
+            <a:r>
+              <a:rPr lang="en-US" sz="1400" b="1" dirty="0">
                 <a:solidFill>
                   <a:srgbClr val="FFFFFF"/>
                 </a:solidFill>
@@ -7596,105 +9115,77 @@
                 <a:ea typeface="Calibri" pitchFamily="34" charset="-122"/>
                 <a:cs typeface="Calibri" pitchFamily="34" charset="-120"/>
               </a:rPr>
-              <a:t>Ich teile dir deine aktuelle mündliche Note mit – mit einer kurzen Begründung.</a:t>
-            </a:r>
-            <a:endParaRPr lang="en-US" sz="2200" dirty="0"/>
-          </a:p>
-        </p:txBody>
-      </p:sp>
-      <p:sp>
-        <p:nvSpPr>
-          <p:cNvPr id="6" name="Text 4"/>
-          <p:cNvSpPr txBox="1"/>
-          <p:nvPr/>
-        </p:nvSpPr>
-        <p:spPr>
-          <a:xfrm>
-            <a:off x="822960" y="3611880"/>
-            <a:ext cx="10515600" cy="640080"/>
-          </a:xfrm>
-          <a:prstGeom prst="rect">
-            <a:avLst/>
-          </a:prstGeom>
-          <a:noFill/>
-          <a:ln/>
-        </p:spPr>
-        <p:txBody>
-          <a:bodyPr wrap="square" lIns="0" tIns="0" rIns="0" bIns="0" rtlCol="0" anchor="t"/>
-          <a:lstStyle/>
-          <a:p>
-            <a:pPr indent="0" marL="0">
-              <a:buNone/>
-            </a:pPr>
-            <a:r>
-              <a:rPr lang="en-US" sz="2200" b="1" dirty="0">
-                <a:solidFill>
-                  <a:srgbClr val="E8A33D"/>
-                </a:solidFill>
-                <a:latin typeface="Calibri" pitchFamily="34" charset="0"/>
-                <a:ea typeface="Calibri" pitchFamily="34" charset="-122"/>
-                <a:cs typeface="Calibri" pitchFamily="34" charset="-120"/>
-              </a:rPr>
-              <a:t>2  </a:t>
-            </a:r>
-            <a:pPr indent="0" marL="0">
-              <a:buNone/>
-            </a:pPr>
-            <a:r>
-              <a:rPr lang="en-US" sz="2200" dirty="0">
+              <a:t>Stufe 1</a:t>
+            </a:r>
+            <a:endParaRPr lang="en-US" sz="1400" dirty="0"/>
+          </a:p>
+        </p:txBody>
+      </p:sp>
+      <p:sp>
+        <p:nvSpPr>
+          <p:cNvPr id="9" name="Text 6"/>
+          <p:cNvSpPr txBox="1"/>
+          <p:nvPr/>
+        </p:nvSpPr>
+        <p:spPr>
+          <a:xfrm>
+            <a:off x="640080" y="4434840"/>
+            <a:ext cx="1920240" cy="685800"/>
+          </a:xfrm>
+          <a:prstGeom prst="rect">
+            <a:avLst/>
+          </a:prstGeom>
+          <a:noFill/>
+          <a:ln/>
+        </p:spPr>
+        <p:txBody>
+          <a:bodyPr wrap="square" lIns="0" tIns="0" rIns="0" bIns="0" rtlCol="0" anchor="t"/>
+          <a:lstStyle/>
+          <a:p>
+            <a:pPr algn="ctr" indent="0" marL="0">
+              <a:buNone/>
+            </a:pPr>
+            <a:r>
+              <a:rPr lang="en-US" sz="1800" b="1" dirty="0">
                 <a:solidFill>
                   <a:srgbClr val="FFFFFF"/>
                 </a:solidFill>
-                <a:latin typeface="Calibri" pitchFamily="34" charset="0"/>
-                <a:ea typeface="Calibri" pitchFamily="34" charset="-122"/>
-                <a:cs typeface="Calibri" pitchFamily="34" charset="-120"/>
-              </a:rPr>
-              <a:t>Überleg dir: Welche Stufe willst du bis Weihnachten erreichen?</a:t>
-            </a:r>
-            <a:endParaRPr lang="en-US" sz="2200" dirty="0"/>
-          </a:p>
-        </p:txBody>
-      </p:sp>
-      <p:sp>
-        <p:nvSpPr>
-          <p:cNvPr id="7" name="Text 5"/>
-          <p:cNvSpPr txBox="1"/>
-          <p:nvPr/>
-        </p:nvSpPr>
-        <p:spPr>
-          <a:xfrm>
-            <a:off x="822960" y="4389120"/>
-            <a:ext cx="10515600" cy="640080"/>
-          </a:xfrm>
-          <a:prstGeom prst="rect">
-            <a:avLst/>
-          </a:prstGeom>
-          <a:noFill/>
-          <a:ln/>
-        </p:spPr>
-        <p:txBody>
-          <a:bodyPr wrap="square" lIns="0" tIns="0" rIns="0" bIns="0" rtlCol="0" anchor="t"/>
-          <a:lstStyle/>
-          <a:p>
-            <a:pPr indent="0" marL="0">
-              <a:buNone/>
-            </a:pPr>
-            <a:r>
-              <a:rPr lang="en-US" sz="2200" b="1" dirty="0">
-                <a:solidFill>
-                  <a:srgbClr val="E8A33D"/>
-                </a:solidFill>
-                <a:latin typeface="Calibri" pitchFamily="34" charset="0"/>
-                <a:ea typeface="Calibri" pitchFamily="34" charset="-122"/>
-                <a:cs typeface="Calibri" pitchFamily="34" charset="-120"/>
-              </a:rPr>
-              <a:t>3  </a:t>
-            </a:r>
-            <a:pPr indent="0" marL="0">
-              <a:buNone/>
-            </a:pPr>
-            <a:r>
-              <a:rPr lang="en-US" sz="2200" dirty="0">
+                <a:latin typeface="Cambria" pitchFamily="34" charset="0"/>
+                <a:ea typeface="Cambria" pitchFamily="34" charset="-122"/>
+                <a:cs typeface="Cambria" pitchFamily="34" charset="-120"/>
+              </a:rPr>
+              <a:t>Hinweis</a:t>
+            </a:r>
+            <a:endParaRPr lang="en-US" sz="1800" dirty="0"/>
+          </a:p>
+        </p:txBody>
+      </p:sp>
+      <p:sp>
+        <p:nvSpPr>
+          <p:cNvPr id="10" name="Text 7"/>
+          <p:cNvSpPr txBox="1"/>
+          <p:nvPr/>
+        </p:nvSpPr>
+        <p:spPr>
+          <a:xfrm>
+            <a:off x="658368" y="5120640"/>
+            <a:ext cx="1883664" cy="868680"/>
+          </a:xfrm>
+          <a:prstGeom prst="rect">
+            <a:avLst/>
+          </a:prstGeom>
+          <a:noFill/>
+          <a:ln/>
+        </p:spPr>
+        <p:txBody>
+          <a:bodyPr wrap="square" lIns="0" tIns="0" rIns="0" bIns="0" rtlCol="0" anchor="t"/>
+          <a:lstStyle/>
+          <a:p>
+            <a:pPr algn="ctr" indent="0" marL="0">
+              <a:buNone/>
+            </a:pPr>
+            <a:r>
+              <a:rPr lang="en-US" sz="1300" dirty="0">
                 <a:solidFill>
                   <a:srgbClr val="FFFFFF"/>
                 </a:solidFill>
@@ -7702,48 +9193,604 @@
                 <a:ea typeface="Calibri" pitchFamily="34" charset="-122"/>
                 <a:cs typeface="Calibri" pitchFamily="34" charset="-120"/>
               </a:rPr>
-              <a:t>Schreib einen Tipp von der letzten Folie ins Heft, an dem du arbeitest.</a:t>
-            </a:r>
-            <a:endParaRPr lang="en-US" sz="2200" dirty="0"/>
-          </a:p>
-        </p:txBody>
-      </p:sp>
-      <p:sp>
-        <p:nvSpPr>
-          <p:cNvPr id="8" name="Text 6"/>
-          <p:cNvSpPr txBox="1"/>
-          <p:nvPr/>
-        </p:nvSpPr>
-        <p:spPr>
-          <a:xfrm>
-            <a:off x="822960" y="6217920"/>
-            <a:ext cx="10058400" cy="274320"/>
-          </a:xfrm>
-          <a:prstGeom prst="rect">
-            <a:avLst/>
-          </a:prstGeom>
-          <a:noFill/>
-          <a:ln/>
-        </p:spPr>
-        <p:txBody>
-          <a:bodyPr wrap="square" lIns="0" tIns="0" rIns="0" bIns="0" rtlCol="0" anchor="t"/>
-          <a:lstStyle/>
-          <a:p>
-            <a:pPr indent="0" marL="0">
-              <a:buNone/>
-            </a:pPr>
-            <a:r>
-              <a:rPr lang="en-US" sz="1100" dirty="0">
-                <a:solidFill>
-                  <a:srgbClr val="CADCFC"/>
-                </a:solidFill>
-                <a:latin typeface="Calibri" pitchFamily="34" charset="0"/>
-                <a:ea typeface="Calibri" pitchFamily="34" charset="-122"/>
-                <a:cs typeface="Calibri" pitchFamily="34" charset="-120"/>
-              </a:rPr>
-              <a:t>Grundlage: Kriterien zur Beurteilung der mündlichen Leistung (lehrerfreund.de)</a:t>
-            </a:r>
-            <a:endParaRPr lang="en-US" sz="1100" dirty="0"/>
+              <a:t>Blick, Zeichen oder Name – ohne Unterbrechung</a:t>
+            </a:r>
+            <a:endParaRPr lang="en-US" sz="1300" dirty="0"/>
+          </a:p>
+        </p:txBody>
+      </p:sp>
+      <p:sp>
+        <p:nvSpPr>
+          <p:cNvPr id="11" name="Shape 8"/>
+          <p:cNvSpPr/>
+          <p:nvPr/>
+        </p:nvSpPr>
+        <p:spPr>
+          <a:xfrm>
+            <a:off x="2788920" y="3547872"/>
+            <a:ext cx="2103120" cy="2487168"/>
+          </a:xfrm>
+          <a:prstGeom prst="roundRect">
+            <a:avLst>
+              <a:gd name="adj" fmla="val 2174"/>
+            </a:avLst>
+          </a:prstGeom>
+          <a:solidFill>
+            <a:srgbClr val="E8A33D"/>
+          </a:solidFill>
+          <a:ln/>
+        </p:spPr>
+      </p:sp>
+      <p:sp>
+        <p:nvSpPr>
+          <p:cNvPr id="12" name="Text 9"/>
+          <p:cNvSpPr txBox="1"/>
+          <p:nvPr/>
+        </p:nvSpPr>
+        <p:spPr>
+          <a:xfrm>
+            <a:off x="2788920" y="3685032"/>
+            <a:ext cx="2103120" cy="365760"/>
+          </a:xfrm>
+          <a:prstGeom prst="rect">
+            <a:avLst/>
+          </a:prstGeom>
+          <a:noFill/>
+          <a:ln/>
+        </p:spPr>
+        <p:txBody>
+          <a:bodyPr wrap="square" lIns="0" tIns="0" rIns="0" bIns="0" rtlCol="0" anchor="t"/>
+          <a:lstStyle/>
+          <a:p>
+            <a:pPr algn="ctr" indent="0" marL="0">
+              <a:buNone/>
+            </a:pPr>
+            <a:r>
+              <a:rPr lang="en-US" sz="1400" b="1" dirty="0">
+                <a:solidFill>
+                  <a:srgbClr val="FFFFFF"/>
+                </a:solidFill>
+                <a:latin typeface="Calibri" pitchFamily="34" charset="0"/>
+                <a:ea typeface="Calibri" pitchFamily="34" charset="-122"/>
+                <a:cs typeface="Calibri" pitchFamily="34" charset="-120"/>
+              </a:rPr>
+              <a:t>Stufe 2</a:t>
+            </a:r>
+            <a:endParaRPr lang="en-US" sz="1400" dirty="0"/>
+          </a:p>
+        </p:txBody>
+      </p:sp>
+      <p:sp>
+        <p:nvSpPr>
+          <p:cNvPr id="13" name="Text 10"/>
+          <p:cNvSpPr txBox="1"/>
+          <p:nvPr/>
+        </p:nvSpPr>
+        <p:spPr>
+          <a:xfrm>
+            <a:off x="2880360" y="4050792"/>
+            <a:ext cx="1920240" cy="685800"/>
+          </a:xfrm>
+          <a:prstGeom prst="rect">
+            <a:avLst/>
+          </a:prstGeom>
+          <a:noFill/>
+          <a:ln/>
+        </p:spPr>
+        <p:txBody>
+          <a:bodyPr wrap="square" lIns="0" tIns="0" rIns="0" bIns="0" rtlCol="0" anchor="t"/>
+          <a:lstStyle/>
+          <a:p>
+            <a:pPr algn="ctr" indent="0" marL="0">
+              <a:buNone/>
+            </a:pPr>
+            <a:r>
+              <a:rPr lang="en-US" sz="1800" b="1" dirty="0">
+                <a:solidFill>
+                  <a:srgbClr val="FFFFFF"/>
+                </a:solidFill>
+                <a:latin typeface="Cambria" pitchFamily="34" charset="0"/>
+                <a:ea typeface="Cambria" pitchFamily="34" charset="-122"/>
+                <a:cs typeface="Cambria" pitchFamily="34" charset="-120"/>
+              </a:rPr>
+              <a:t>Ermahnung</a:t>
+            </a:r>
+            <a:endParaRPr lang="en-US" sz="1800" dirty="0"/>
+          </a:p>
+        </p:txBody>
+      </p:sp>
+      <p:sp>
+        <p:nvSpPr>
+          <p:cNvPr id="14" name="Text 11"/>
+          <p:cNvSpPr txBox="1"/>
+          <p:nvPr/>
+        </p:nvSpPr>
+        <p:spPr>
+          <a:xfrm>
+            <a:off x="2898648" y="4736592"/>
+            <a:ext cx="1883664" cy="1252728"/>
+          </a:xfrm>
+          <a:prstGeom prst="rect">
+            <a:avLst/>
+          </a:prstGeom>
+          <a:noFill/>
+          <a:ln/>
+        </p:spPr>
+        <p:txBody>
+          <a:bodyPr wrap="square" lIns="0" tIns="0" rIns="0" bIns="0" rtlCol="0" anchor="t"/>
+          <a:lstStyle/>
+          <a:p>
+            <a:pPr algn="ctr" indent="0" marL="0">
+              <a:buNone/>
+            </a:pPr>
+            <a:r>
+              <a:rPr lang="en-US" sz="1300" dirty="0">
+                <a:solidFill>
+                  <a:srgbClr val="FFFFFF"/>
+                </a:solidFill>
+                <a:latin typeface="Calibri" pitchFamily="34" charset="0"/>
+                <a:ea typeface="Calibri" pitchFamily="34" charset="-122"/>
+                <a:cs typeface="Calibri" pitchFamily="34" charset="-120"/>
+              </a:rPr>
+              <a:t>deutliche Ansage vor der Klasse</a:t>
+            </a:r>
+            <a:endParaRPr lang="en-US" sz="1300" dirty="0"/>
+          </a:p>
+        </p:txBody>
+      </p:sp>
+      <p:sp>
+        <p:nvSpPr>
+          <p:cNvPr id="15" name="Shape 12"/>
+          <p:cNvSpPr/>
+          <p:nvPr/>
+        </p:nvSpPr>
+        <p:spPr>
+          <a:xfrm>
+            <a:off x="5029200" y="3163824"/>
+            <a:ext cx="2103120" cy="2871216"/>
+          </a:xfrm>
+          <a:prstGeom prst="roundRect">
+            <a:avLst>
+              <a:gd name="adj" fmla="val 2174"/>
+            </a:avLst>
+          </a:prstGeom>
+          <a:solidFill>
+            <a:srgbClr val="E07B45"/>
+          </a:solidFill>
+          <a:ln/>
+        </p:spPr>
+      </p:sp>
+      <p:sp>
+        <p:nvSpPr>
+          <p:cNvPr id="16" name="Text 13"/>
+          <p:cNvSpPr txBox="1"/>
+          <p:nvPr/>
+        </p:nvSpPr>
+        <p:spPr>
+          <a:xfrm>
+            <a:off x="5029200" y="3300984"/>
+            <a:ext cx="2103120" cy="365760"/>
+          </a:xfrm>
+          <a:prstGeom prst="rect">
+            <a:avLst/>
+          </a:prstGeom>
+          <a:noFill/>
+          <a:ln/>
+        </p:spPr>
+        <p:txBody>
+          <a:bodyPr wrap="square" lIns="0" tIns="0" rIns="0" bIns="0" rtlCol="0" anchor="t"/>
+          <a:lstStyle/>
+          <a:p>
+            <a:pPr algn="ctr" indent="0" marL="0">
+              <a:buNone/>
+            </a:pPr>
+            <a:r>
+              <a:rPr lang="en-US" sz="1400" b="1" dirty="0">
+                <a:solidFill>
+                  <a:srgbClr val="FFFFFF"/>
+                </a:solidFill>
+                <a:latin typeface="Calibri" pitchFamily="34" charset="0"/>
+                <a:ea typeface="Calibri" pitchFamily="34" charset="-122"/>
+                <a:cs typeface="Calibri" pitchFamily="34" charset="-120"/>
+              </a:rPr>
+              <a:t>Stufe 3</a:t>
+            </a:r>
+            <a:endParaRPr lang="en-US" sz="1400" dirty="0"/>
+          </a:p>
+        </p:txBody>
+      </p:sp>
+      <p:sp>
+        <p:nvSpPr>
+          <p:cNvPr id="17" name="Text 14"/>
+          <p:cNvSpPr txBox="1"/>
+          <p:nvPr/>
+        </p:nvSpPr>
+        <p:spPr>
+          <a:xfrm>
+            <a:off x="5120640" y="3666744"/>
+            <a:ext cx="1920240" cy="685800"/>
+          </a:xfrm>
+          <a:prstGeom prst="rect">
+            <a:avLst/>
+          </a:prstGeom>
+          <a:noFill/>
+          <a:ln/>
+        </p:spPr>
+        <p:txBody>
+          <a:bodyPr wrap="square" lIns="0" tIns="0" rIns="0" bIns="0" rtlCol="0" anchor="t"/>
+          <a:lstStyle/>
+          <a:p>
+            <a:pPr algn="ctr" indent="0" marL="0">
+              <a:buNone/>
+            </a:pPr>
+            <a:r>
+              <a:rPr lang="en-US" sz="1800" b="1" dirty="0">
+                <a:solidFill>
+                  <a:srgbClr val="FFFFFF"/>
+                </a:solidFill>
+                <a:latin typeface="Cambria" pitchFamily="34" charset="0"/>
+                <a:ea typeface="Cambria" pitchFamily="34" charset="-122"/>
+                <a:cs typeface="Cambria" pitchFamily="34" charset="-120"/>
+              </a:rPr>
+              <a:t>Notiz</a:t>
+            </a:r>
+            <a:endParaRPr lang="en-US" sz="1800" dirty="0"/>
+          </a:p>
+        </p:txBody>
+      </p:sp>
+      <p:sp>
+        <p:nvSpPr>
+          <p:cNvPr id="18" name="Text 15"/>
+          <p:cNvSpPr txBox="1"/>
+          <p:nvPr/>
+        </p:nvSpPr>
+        <p:spPr>
+          <a:xfrm>
+            <a:off x="5138928" y="4352544"/>
+            <a:ext cx="1883664" cy="1636776"/>
+          </a:xfrm>
+          <a:prstGeom prst="rect">
+            <a:avLst/>
+          </a:prstGeom>
+          <a:noFill/>
+          <a:ln/>
+        </p:spPr>
+        <p:txBody>
+          <a:bodyPr wrap="square" lIns="0" tIns="0" rIns="0" bIns="0" rtlCol="0" anchor="t"/>
+          <a:lstStyle/>
+          <a:p>
+            <a:pPr algn="ctr" indent="0" marL="0">
+              <a:buNone/>
+            </a:pPr>
+            <a:r>
+              <a:rPr lang="en-US" sz="1300" dirty="0">
+                <a:solidFill>
+                  <a:srgbClr val="FFFFFF"/>
+                </a:solidFill>
+                <a:latin typeface="Calibri" pitchFamily="34" charset="0"/>
+                <a:ea typeface="Calibri" pitchFamily="34" charset="-122"/>
+                <a:cs typeface="Calibri" pitchFamily="34" charset="-120"/>
+              </a:rPr>
+              <a:t>Eintrag in meiner Liste, kurzes Gespräch nach der Stunde</a:t>
+            </a:r>
+            <a:endParaRPr lang="en-US" sz="1300" dirty="0"/>
+          </a:p>
+        </p:txBody>
+      </p:sp>
+      <p:sp>
+        <p:nvSpPr>
+          <p:cNvPr id="19" name="Shape 16"/>
+          <p:cNvSpPr/>
+          <p:nvPr/>
+        </p:nvSpPr>
+        <p:spPr>
+          <a:xfrm>
+            <a:off x="7269480" y="2779776"/>
+            <a:ext cx="2103120" cy="3255264"/>
+          </a:xfrm>
+          <a:prstGeom prst="roundRect">
+            <a:avLst>
+              <a:gd name="adj" fmla="val 2174"/>
+            </a:avLst>
+          </a:prstGeom>
+          <a:solidFill>
+            <a:srgbClr val="D9534F"/>
+          </a:solidFill>
+          <a:ln/>
+        </p:spPr>
+      </p:sp>
+      <p:sp>
+        <p:nvSpPr>
+          <p:cNvPr id="20" name="Text 17"/>
+          <p:cNvSpPr txBox="1"/>
+          <p:nvPr/>
+        </p:nvSpPr>
+        <p:spPr>
+          <a:xfrm>
+            <a:off x="7269480" y="2916936"/>
+            <a:ext cx="2103120" cy="365760"/>
+          </a:xfrm>
+          <a:prstGeom prst="rect">
+            <a:avLst/>
+          </a:prstGeom>
+          <a:noFill/>
+          <a:ln/>
+        </p:spPr>
+        <p:txBody>
+          <a:bodyPr wrap="square" lIns="0" tIns="0" rIns="0" bIns="0" rtlCol="0" anchor="t"/>
+          <a:lstStyle/>
+          <a:p>
+            <a:pPr algn="ctr" indent="0" marL="0">
+              <a:buNone/>
+            </a:pPr>
+            <a:r>
+              <a:rPr lang="en-US" sz="1400" b="1" dirty="0">
+                <a:solidFill>
+                  <a:srgbClr val="FFFFFF"/>
+                </a:solidFill>
+                <a:latin typeface="Calibri" pitchFamily="34" charset="0"/>
+                <a:ea typeface="Calibri" pitchFamily="34" charset="-122"/>
+                <a:cs typeface="Calibri" pitchFamily="34" charset="-120"/>
+              </a:rPr>
+              <a:t>Stufe 4</a:t>
+            </a:r>
+            <a:endParaRPr lang="en-US" sz="1400" dirty="0"/>
+          </a:p>
+        </p:txBody>
+      </p:sp>
+      <p:sp>
+        <p:nvSpPr>
+          <p:cNvPr id="21" name="Text 18"/>
+          <p:cNvSpPr txBox="1"/>
+          <p:nvPr/>
+        </p:nvSpPr>
+        <p:spPr>
+          <a:xfrm>
+            <a:off x="7360920" y="3282696"/>
+            <a:ext cx="1920240" cy="685800"/>
+          </a:xfrm>
+          <a:prstGeom prst="rect">
+            <a:avLst/>
+          </a:prstGeom>
+          <a:noFill/>
+          <a:ln/>
+        </p:spPr>
+        <p:txBody>
+          <a:bodyPr wrap="square" lIns="0" tIns="0" rIns="0" bIns="0" rtlCol="0" anchor="t"/>
+          <a:lstStyle/>
+          <a:p>
+            <a:pPr algn="ctr" indent="0" marL="0">
+              <a:buNone/>
+            </a:pPr>
+            <a:r>
+              <a:rPr lang="en-US" sz="1800" b="1" dirty="0">
+                <a:solidFill>
+                  <a:srgbClr val="FFFFFF"/>
+                </a:solidFill>
+                <a:latin typeface="Cambria" pitchFamily="34" charset="0"/>
+                <a:ea typeface="Cambria" pitchFamily="34" charset="-122"/>
+                <a:cs typeface="Cambria" pitchFamily="34" charset="-120"/>
+              </a:rPr>
+              <a:t>Konsequenz</a:t>
+            </a:r>
+            <a:endParaRPr lang="en-US" sz="1800" dirty="0"/>
+          </a:p>
+        </p:txBody>
+      </p:sp>
+      <p:sp>
+        <p:nvSpPr>
+          <p:cNvPr id="22" name="Text 19"/>
+          <p:cNvSpPr txBox="1"/>
+          <p:nvPr/>
+        </p:nvSpPr>
+        <p:spPr>
+          <a:xfrm>
+            <a:off x="7379208" y="3968496"/>
+            <a:ext cx="1883664" cy="2020824"/>
+          </a:xfrm>
+          <a:prstGeom prst="rect">
+            <a:avLst/>
+          </a:prstGeom>
+          <a:noFill/>
+          <a:ln/>
+        </p:spPr>
+        <p:txBody>
+          <a:bodyPr wrap="square" lIns="0" tIns="0" rIns="0" bIns="0" rtlCol="0" anchor="t"/>
+          <a:lstStyle/>
+          <a:p>
+            <a:pPr algn="ctr" indent="0" marL="0">
+              <a:buNone/>
+            </a:pPr>
+            <a:r>
+              <a:rPr lang="en-US" sz="1300" dirty="0">
+                <a:solidFill>
+                  <a:srgbClr val="FFFFFF"/>
+                </a:solidFill>
+                <a:latin typeface="Calibri" pitchFamily="34" charset="0"/>
+                <a:ea typeface="Calibri" pitchFamily="34" charset="-122"/>
+                <a:cs typeface="Calibri" pitchFamily="34" charset="-120"/>
+              </a:rPr>
+              <a:t>Umsetzen, Zusatzaufgabe oder Nacharbeit</a:t>
+            </a:r>
+            <a:endParaRPr lang="en-US" sz="1300" dirty="0"/>
+          </a:p>
+        </p:txBody>
+      </p:sp>
+      <p:sp>
+        <p:nvSpPr>
+          <p:cNvPr id="23" name="Shape 20"/>
+          <p:cNvSpPr/>
+          <p:nvPr/>
+        </p:nvSpPr>
+        <p:spPr>
+          <a:xfrm>
+            <a:off x="9509760" y="2395728"/>
+            <a:ext cx="2103120" cy="3639312"/>
+          </a:xfrm>
+          <a:prstGeom prst="roundRect">
+            <a:avLst>
+              <a:gd name="adj" fmla="val 2174"/>
+            </a:avLst>
+          </a:prstGeom>
+          <a:solidFill>
+            <a:srgbClr val="A93A36"/>
+          </a:solidFill>
+          <a:ln/>
+        </p:spPr>
+      </p:sp>
+      <p:sp>
+        <p:nvSpPr>
+          <p:cNvPr id="24" name="Text 21"/>
+          <p:cNvSpPr txBox="1"/>
+          <p:nvPr/>
+        </p:nvSpPr>
+        <p:spPr>
+          <a:xfrm>
+            <a:off x="9509760" y="2532888"/>
+            <a:ext cx="2103120" cy="365760"/>
+          </a:xfrm>
+          <a:prstGeom prst="rect">
+            <a:avLst/>
+          </a:prstGeom>
+          <a:noFill/>
+          <a:ln/>
+        </p:spPr>
+        <p:txBody>
+          <a:bodyPr wrap="square" lIns="0" tIns="0" rIns="0" bIns="0" rtlCol="0" anchor="t"/>
+          <a:lstStyle/>
+          <a:p>
+            <a:pPr algn="ctr" indent="0" marL="0">
+              <a:buNone/>
+            </a:pPr>
+            <a:r>
+              <a:rPr lang="en-US" sz="1400" b="1" dirty="0">
+                <a:solidFill>
+                  <a:srgbClr val="FFFFFF"/>
+                </a:solidFill>
+                <a:latin typeface="Calibri" pitchFamily="34" charset="0"/>
+                <a:ea typeface="Calibri" pitchFamily="34" charset="-122"/>
+                <a:cs typeface="Calibri" pitchFamily="34" charset="-120"/>
+              </a:rPr>
+              <a:t>Stufe 5</a:t>
+            </a:r>
+            <a:endParaRPr lang="en-US" sz="1400" dirty="0"/>
+          </a:p>
+        </p:txBody>
+      </p:sp>
+      <p:sp>
+        <p:nvSpPr>
+          <p:cNvPr id="25" name="Text 22"/>
+          <p:cNvSpPr txBox="1"/>
+          <p:nvPr/>
+        </p:nvSpPr>
+        <p:spPr>
+          <a:xfrm>
+            <a:off x="9601200" y="2898648"/>
+            <a:ext cx="1920240" cy="685800"/>
+          </a:xfrm>
+          <a:prstGeom prst="rect">
+            <a:avLst/>
+          </a:prstGeom>
+          <a:noFill/>
+          <a:ln/>
+        </p:spPr>
+        <p:txBody>
+          <a:bodyPr wrap="square" lIns="0" tIns="0" rIns="0" bIns="0" rtlCol="0" anchor="t"/>
+          <a:lstStyle/>
+          <a:p>
+            <a:pPr algn="ctr" indent="0" marL="0">
+              <a:buNone/>
+            </a:pPr>
+            <a:r>
+              <a:rPr lang="en-US" sz="1800" b="1" dirty="0">
+                <a:solidFill>
+                  <a:srgbClr val="FFFFFF"/>
+                </a:solidFill>
+                <a:latin typeface="Cambria" pitchFamily="34" charset="0"/>
+                <a:ea typeface="Cambria" pitchFamily="34" charset="-122"/>
+                <a:cs typeface="Cambria" pitchFamily="34" charset="-120"/>
+              </a:rPr>
+              <a:t>Eltern und Klassenleitung</a:t>
+            </a:r>
+            <a:endParaRPr lang="en-US" sz="1800" dirty="0"/>
+          </a:p>
+        </p:txBody>
+      </p:sp>
+      <p:sp>
+        <p:nvSpPr>
+          <p:cNvPr id="26" name="Text 23"/>
+          <p:cNvSpPr txBox="1"/>
+          <p:nvPr/>
+        </p:nvSpPr>
+        <p:spPr>
+          <a:xfrm>
+            <a:off x="9619488" y="3584448"/>
+            <a:ext cx="1883664" cy="2404872"/>
+          </a:xfrm>
+          <a:prstGeom prst="rect">
+            <a:avLst/>
+          </a:prstGeom>
+          <a:noFill/>
+          <a:ln/>
+        </p:spPr>
+        <p:txBody>
+          <a:bodyPr wrap="square" lIns="0" tIns="0" rIns="0" bIns="0" rtlCol="0" anchor="t"/>
+          <a:lstStyle/>
+          <a:p>
+            <a:pPr algn="ctr" indent="0" marL="0">
+              <a:buNone/>
+            </a:pPr>
+            <a:r>
+              <a:rPr lang="en-US" sz="1300" dirty="0">
+                <a:solidFill>
+                  <a:srgbClr val="FFFFFF"/>
+                </a:solidFill>
+                <a:latin typeface="Calibri" pitchFamily="34" charset="0"/>
+                <a:ea typeface="Calibri" pitchFamily="34" charset="-122"/>
+                <a:cs typeface="Calibri" pitchFamily="34" charset="-120"/>
+              </a:rPr>
+              <a:t>Information, Eintrag, gemeinsames Gespräch</a:t>
+            </a:r>
+            <a:endParaRPr lang="en-US" sz="1300" dirty="0"/>
+          </a:p>
+        </p:txBody>
+      </p:sp>
+      <p:sp>
+        <p:nvSpPr>
+          <p:cNvPr id="27" name="Text 24"/>
+          <p:cNvSpPr txBox="1"/>
+          <p:nvPr/>
+        </p:nvSpPr>
+        <p:spPr>
+          <a:xfrm>
+            <a:off x="548640" y="1508760"/>
+            <a:ext cx="6400800" cy="731520"/>
+          </a:xfrm>
+          <a:prstGeom prst="rect">
+            <a:avLst/>
+          </a:prstGeom>
+          <a:noFill/>
+          <a:ln/>
+        </p:spPr>
+        <p:txBody>
+          <a:bodyPr wrap="square" lIns="0" tIns="0" rIns="0" bIns="0" rtlCol="0" anchor="t"/>
+          <a:lstStyle/>
+          <a:p>
+            <a:pPr indent="0" marL="0">
+              <a:buNone/>
+            </a:pPr>
+            <a:r>
+              <a:rPr lang="en-US" sz="1600" i="1" dirty="0">
+                <a:solidFill>
+                  <a:srgbClr val="5B6B8C"/>
+                </a:solidFill>
+                <a:latin typeface="Calibri" pitchFamily="34" charset="0"/>
+                <a:ea typeface="Calibri" pitchFamily="34" charset="-122"/>
+                <a:cs typeface="Calibri" pitchFamily="34" charset="-120"/>
+              </a:rPr>
+              <a:t>Mit jeder Störung in derselben Stunde geht es eine Stufe höher. Die nächste Stunde beginnt wieder bei null.</a:t>
+            </a:r>
+            <a:endParaRPr lang="en-US" sz="1600" dirty="0"/>
           </a:p>
         </p:txBody>
       </p:sp>

</xml_diff>